<commit_message>
Add Lasso with historical validation and five-method report
</commit_message>
<xml_diff>
--- a/Presentation_Group9.pptx
+++ b/Presentation_Group9.pptx
@@ -524,7 +524,7 @@
           <a:lstStyle/>
           <a:p>
             <a:r>
-              <a:t>Suggested speaking time: 20 seconds. Introduce the question: can financial and market signals improve cross-sectional stock selection after stated trading costs? Identify four fixed methods, the common opportunity set and the observed historical dates.</a:t>
+              <a:t>Suggested speaking time: 20 seconds. Introduce the question: can financial and market signals improve cross-sectional stock selection after stated trading costs? Identify five methods, the common opportunity set and the observed historical dates.</a:t>
             </a:r>
           </a:p>
         </p:txBody>
@@ -1224,7 +1224,7 @@
           <a:lstStyle/>
           <a:p>
             <a:r>
-              <a:t>Suggested speaking time: 65 seconds. The left panel compares raw-signal and adopted twenty-session net returns for all four methods in 2021–2025. The right panel compares 2026 Ridge daily, twenty-session and daily doubled-slippage summed net excess. Retain weaker comparisons. Do not call the daily doubled-slippage case a twenty-session stress, or treat a displayed latest-year best case as an independent strategy discovery.</a:t>
+              <a:t>Suggested speaking time: 65 seconds. Explain the L1 versus L2 comparison using the displayed annual sparse coefficient counts and matched returns. For each year, internal training labels exit before previous-calendar-year validation starts; validation labels exit before the forecast year. Compare 15 alpha fractions with equal-date mean validation MSE, then refit on all mature history. The alpha scale is not Ridge's alpha scale. State whether sparsity actually occurs: Lasso may retain every input. An all-zero annual fit emits no score, so the next scheduled target requests cash subject to blocked-sale constraints; there is no arbitrary code-order Top-100 ranking. Prediction loss and fee-paying Top-100 returns are different objectives. The already reviewed 2026 history is not a new blind test.</a:t>
             </a:r>
           </a:p>
         </p:txBody>
@@ -1294,7 +1294,7 @@
           <a:lstStyle/>
           <a:p>
             <a:r>
-              <a:t>Suggested speaking time: 70 seconds. Read the table before focusing on Ridge. The 2021–2025 net return is 195.66% versus 76.60% for the matched pool. In 2026 through 29 April, Ridge earns 8.80% net and +0.56 percentage points of summed daily excess. Combined has a higher partial-year return, while Fundamental and LightGBM lag the pool. Absolute returns compound; excess sums daily differences.</a:t>
+              <a:t>Suggested speaking time: 70 seconds. Read every method, including Lasso: its 2021–2025 net return is 96.10%, and its 2026 net return is 7.52%. Ridge remains the original reference implementation. Compare net returns and summed daily excess separately. Absolute returns compound; excess sums daily differences.</a:t>
             </a:r>
           </a:p>
         </p:txBody>
@@ -1924,7 +1924,7 @@
           <a:lstStyle/>
           <a:p>
             <a:r>
-              <a:t>Suggested speaking time: 50 seconds. Read the complete gross return history. Include all four methods and the pool rather than only the winner. Wealth compounds daily portfolio returns. The initial flat section precedes feasible trading, and the early history is fitted replay. There is no yearly restart or clipped weak interval.</a:t>
+              <a:t>Suggested speaking time: 50 seconds. Read the complete gross return history. Include all five methods and the pool rather than only the winner. Wealth compounds daily portfolio returns. The initial flat section precedes feasible trading, and the early history is fitted replay. There is no yearly restart or clipped weak interval.</a:t>
             </a:r>
           </a:p>
         </p:txBody>
@@ -7608,7 +7608,7 @@
               </a:defRPr>
             </a:pPr>
             <a:r>
-              <a:t>Raw signals and implementation controls</a:t>
+              <a:t>Lasso: sparse model, matched experiment</a:t>
             </a:r>
           </a:p>
         </p:txBody>
@@ -7653,35 +7653,1369 @@
               </a:defRPr>
             </a:pPr>
             <a:r>
-              <a:t>2021–2025 designs on the left; 2026 Ridge cadence / cost controls on the right</a:t>
-            </a:r>
-          </a:p>
-        </p:txBody>
-      </p:sp>
-      <p:pic>
-        <p:nvPicPr>
-          <p:cNvPr id="4" name="Picture 3" descr="controls_slide.png"/>
-          <p:cNvPicPr>
-            <a:picLocks noChangeAspect="1"/>
-          </p:cNvPicPr>
+              <a:t>Same eight inputs, EMA20 and execution as Ridge; L1 rather than L2 penalty</a:t>
+            </a:r>
+          </a:p>
+        </p:txBody>
+      </p:sp>
+      <p:graphicFrame>
+        <p:nvGraphicFramePr>
+          <p:cNvPr id="4" name="Table 3"/>
+          <p:cNvGraphicFramePr>
+            <a:graphicFrameLocks noGrp="1"/>
+          </p:cNvGraphicFramePr>
           <p:nvPr/>
-        </p:nvPicPr>
-        <p:blipFill>
-          <a:blip r:embed="rId2"/>
-          <a:stretch>
-            <a:fillRect/>
-          </a:stretch>
-        </p:blipFill>
-        <p:spPr>
-          <a:xfrm>
-            <a:off x="1257300" y="1719071"/>
-            <a:ext cx="9692640" cy="3840480"/>
-          </a:xfrm>
-          <a:prstGeom prst="rect">
-            <a:avLst/>
-          </a:prstGeom>
-        </p:spPr>
-      </p:pic>
+        </p:nvGraphicFramePr>
+        <p:xfrm>
+          <a:off x="777240" y="1691640"/>
+          <a:ext cx="10607040" cy="2816352"/>
+        </p:xfrm>
+        <a:graphic>
+          <a:graphicData uri="http://schemas.openxmlformats.org/drawingml/2006/table">
+            <a:tbl>
+              <a:tblPr>
+                <a:tableStyleId>{5C22544A-7EE6-4342-B048-85BDC9FD1C3A}</a:tableStyleId>
+              </a:tblPr>
+              <a:tblGrid>
+                <a:gridCol w="2011680"/>
+                <a:gridCol w="2331720"/>
+                <a:gridCol w="2240280"/>
+                <a:gridCol w="4023360"/>
+              </a:tblGrid>
+              <a:tr h="402336">
+                <a:tc>
+                  <a:txBody>
+                    <a:bodyPr wrap="none"/>
+                    <a:lstStyle/>
+                    <a:p>
+                      <a:pPr algn="l">
+                        <a:lnSpc>
+                          <a:spcPts val="1980"/>
+                        </a:lnSpc>
+                        <a:spcBef>
+                          <a:spcPts val="0"/>
+                        </a:spcBef>
+                        <a:spcAft>
+                          <a:spcPts val="0"/>
+                        </a:spcAft>
+                        <a:defRPr sz="1800" b="1">
+                          <a:solidFill>
+                            <a:srgbClr val="17212D"/>
+                          </a:solidFill>
+                          <a:latin typeface="DejaVu Sans"/>
+                        </a:defRPr>
+                      </a:pPr>
+                      <a:r>
+                        <a:t>Fit year</a:t>
+                      </a:r>
+                    </a:p>
+                  </a:txBody>
+                  <a:tcPr marL="82296" marR="82296" marT="91440" marB="0" anchor="t">
+                    <a:lnL w="6350">
+                      <a:noFill/>
+                    </a:lnL>
+                    <a:lnR w="6350">
+                      <a:noFill/>
+                    </a:lnR>
+                    <a:lnT w="6350">
+                      <a:noFill/>
+                    </a:lnT>
+                    <a:lnB w="6350">
+                      <a:solidFill>
+                        <a:srgbClr val="D9DEE3"/>
+                      </a:solidFill>
+                    </a:lnB>
+                    <a:solidFill>
+                      <a:srgbClr val="F2F4F5"/>
+                    </a:solidFill>
+                  </a:tcPr>
+                </a:tc>
+                <a:tc>
+                  <a:txBody>
+                    <a:bodyPr wrap="none"/>
+                    <a:lstStyle/>
+                    <a:p>
+                      <a:pPr algn="r">
+                        <a:lnSpc>
+                          <a:spcPts val="1980"/>
+                        </a:lnSpc>
+                        <a:spcBef>
+                          <a:spcPts val="0"/>
+                        </a:spcBef>
+                        <a:spcAft>
+                          <a:spcPts val="0"/>
+                        </a:spcAft>
+                        <a:defRPr sz="1800" b="1">
+                          <a:solidFill>
+                            <a:srgbClr val="17212D"/>
+                          </a:solidFill>
+                          <a:latin typeface="DejaVu Sans"/>
+                        </a:defRPr>
+                      </a:pPr>
+                      <a:r>
+                        <a:t>Alpha</a:t>
+                      </a:r>
+                    </a:p>
+                  </a:txBody>
+                  <a:tcPr marL="82296" marR="82296" marT="91440" marB="0" anchor="t">
+                    <a:lnL w="6350">
+                      <a:noFill/>
+                    </a:lnL>
+                    <a:lnR w="6350">
+                      <a:noFill/>
+                    </a:lnR>
+                    <a:lnT w="6350">
+                      <a:noFill/>
+                    </a:lnT>
+                    <a:lnB w="6350">
+                      <a:solidFill>
+                        <a:srgbClr val="D9DEE3"/>
+                      </a:solidFill>
+                    </a:lnB>
+                    <a:solidFill>
+                      <a:srgbClr val="F2F4F5"/>
+                    </a:solidFill>
+                  </a:tcPr>
+                </a:tc>
+                <a:tc>
+                  <a:txBody>
+                    <a:bodyPr wrap="none"/>
+                    <a:lstStyle/>
+                    <a:p>
+                      <a:pPr algn="r">
+                        <a:lnSpc>
+                          <a:spcPts val="1980"/>
+                        </a:lnSpc>
+                        <a:spcBef>
+                          <a:spcPts val="0"/>
+                        </a:spcBef>
+                        <a:spcAft>
+                          <a:spcPts val="0"/>
+                        </a:spcAft>
+                        <a:defRPr sz="1800" b="1">
+                          <a:solidFill>
+                            <a:srgbClr val="17212D"/>
+                          </a:solidFill>
+                          <a:latin typeface="DejaVu Sans"/>
+                        </a:defRPr>
+                      </a:pPr>
+                      <a:r>
+                        <a:t>Nonzero / 8</a:t>
+                      </a:r>
+                    </a:p>
+                  </a:txBody>
+                  <a:tcPr marL="82296" marR="82296" marT="91440" marB="0" anchor="t">
+                    <a:lnL w="6350">
+                      <a:noFill/>
+                    </a:lnL>
+                    <a:lnR w="6350">
+                      <a:noFill/>
+                    </a:lnR>
+                    <a:lnT w="6350">
+                      <a:noFill/>
+                    </a:lnT>
+                    <a:lnB w="6350">
+                      <a:solidFill>
+                        <a:srgbClr val="D9DEE3"/>
+                      </a:solidFill>
+                    </a:lnB>
+                    <a:solidFill>
+                      <a:srgbClr val="F2F4F5"/>
+                    </a:solidFill>
+                  </a:tcPr>
+                </a:tc>
+                <a:tc>
+                  <a:txBody>
+                    <a:bodyPr wrap="none"/>
+                    <a:lstStyle/>
+                    <a:p>
+                      <a:pPr algn="r">
+                        <a:lnSpc>
+                          <a:spcPts val="1980"/>
+                        </a:lnSpc>
+                        <a:spcBef>
+                          <a:spcPts val="0"/>
+                        </a:spcBef>
+                        <a:spcAft>
+                          <a:spcPts val="0"/>
+                        </a:spcAft>
+                        <a:defRPr sz="1800" b="1">
+                          <a:solidFill>
+                            <a:srgbClr val="17212D"/>
+                          </a:solidFill>
+                          <a:latin typeface="DejaVu Sans"/>
+                        </a:defRPr>
+                      </a:pPr>
+                      <a:r>
+                        <a:t>Validation</a:t>
+                      </a:r>
+                    </a:p>
+                  </a:txBody>
+                  <a:tcPr marL="82296" marR="82296" marT="91440" marB="0" anchor="t">
+                    <a:lnL w="6350">
+                      <a:noFill/>
+                    </a:lnL>
+                    <a:lnR w="6350">
+                      <a:noFill/>
+                    </a:lnR>
+                    <a:lnT w="6350">
+                      <a:noFill/>
+                    </a:lnT>
+                    <a:lnB w="6350">
+                      <a:solidFill>
+                        <a:srgbClr val="D9DEE3"/>
+                      </a:solidFill>
+                    </a:lnB>
+                    <a:solidFill>
+                      <a:srgbClr val="F2F4F5"/>
+                    </a:solidFill>
+                  </a:tcPr>
+                </a:tc>
+              </a:tr>
+              <a:tr h="402336">
+                <a:tc>
+                  <a:txBody>
+                    <a:bodyPr wrap="none"/>
+                    <a:lstStyle/>
+                    <a:p>
+                      <a:pPr algn="l">
+                        <a:lnSpc>
+                          <a:spcPts val="1980"/>
+                        </a:lnSpc>
+                        <a:spcBef>
+                          <a:spcPts val="0"/>
+                        </a:spcBef>
+                        <a:spcAft>
+                          <a:spcPts val="0"/>
+                        </a:spcAft>
+                        <a:defRPr sz="1800" b="0">
+                          <a:solidFill>
+                            <a:srgbClr val="17212D"/>
+                          </a:solidFill>
+                          <a:latin typeface="DejaVu Sans"/>
+                        </a:defRPr>
+                      </a:pPr>
+                      <a:r>
+                        <a:t>2021</a:t>
+                      </a:r>
+                    </a:p>
+                  </a:txBody>
+                  <a:tcPr marL="82296" marR="82296" marT="91440" marB="0" anchor="t">
+                    <a:lnL w="6350">
+                      <a:noFill/>
+                    </a:lnL>
+                    <a:lnR w="6350">
+                      <a:noFill/>
+                    </a:lnR>
+                    <a:lnT w="6350">
+                      <a:noFill/>
+                    </a:lnT>
+                    <a:lnB w="6350">
+                      <a:solidFill>
+                        <a:srgbClr val="D9DEE3"/>
+                      </a:solidFill>
+                    </a:lnB>
+                    <a:solidFill>
+                      <a:srgbClr val="FFFFFF"/>
+                    </a:solidFill>
+                  </a:tcPr>
+                </a:tc>
+                <a:tc>
+                  <a:txBody>
+                    <a:bodyPr wrap="none"/>
+                    <a:lstStyle/>
+                    <a:p>
+                      <a:pPr algn="r">
+                        <a:lnSpc>
+                          <a:spcPts val="1980"/>
+                        </a:lnSpc>
+                        <a:spcBef>
+                          <a:spcPts val="0"/>
+                        </a:spcBef>
+                        <a:spcAft>
+                          <a:spcPts val="0"/>
+                        </a:spcAft>
+                        <a:defRPr sz="1800" b="0">
+                          <a:solidFill>
+                            <a:srgbClr val="17212D"/>
+                          </a:solidFill>
+                          <a:latin typeface="DejaVu Sans"/>
+                        </a:defRPr>
+                      </a:pPr>
+                      <a:r>
+                        <a:t>0.00114</a:t>
+                      </a:r>
+                    </a:p>
+                  </a:txBody>
+                  <a:tcPr marL="82296" marR="82296" marT="91440" marB="0" anchor="t">
+                    <a:lnL w="6350">
+                      <a:noFill/>
+                    </a:lnL>
+                    <a:lnR w="6350">
+                      <a:noFill/>
+                    </a:lnR>
+                    <a:lnT w="6350">
+                      <a:noFill/>
+                    </a:lnT>
+                    <a:lnB w="6350">
+                      <a:solidFill>
+                        <a:srgbClr val="D9DEE3"/>
+                      </a:solidFill>
+                    </a:lnB>
+                    <a:solidFill>
+                      <a:srgbClr val="FFFFFF"/>
+                    </a:solidFill>
+                  </a:tcPr>
+                </a:tc>
+                <a:tc>
+                  <a:txBody>
+                    <a:bodyPr wrap="none"/>
+                    <a:lstStyle/>
+                    <a:p>
+                      <a:pPr algn="r">
+                        <a:lnSpc>
+                          <a:spcPts val="1980"/>
+                        </a:lnSpc>
+                        <a:spcBef>
+                          <a:spcPts val="0"/>
+                        </a:spcBef>
+                        <a:spcAft>
+                          <a:spcPts val="0"/>
+                        </a:spcAft>
+                        <a:defRPr sz="1800" b="0">
+                          <a:solidFill>
+                            <a:srgbClr val="17212D"/>
+                          </a:solidFill>
+                          <a:latin typeface="DejaVu Sans"/>
+                        </a:defRPr>
+                      </a:pPr>
+                      <a:r>
+                        <a:t>0</a:t>
+                      </a:r>
+                    </a:p>
+                  </a:txBody>
+                  <a:tcPr marL="82296" marR="82296" marT="91440" marB="0" anchor="t">
+                    <a:lnL w="6350">
+                      <a:noFill/>
+                    </a:lnL>
+                    <a:lnR w="6350">
+                      <a:noFill/>
+                    </a:lnR>
+                    <a:lnT w="6350">
+                      <a:noFill/>
+                    </a:lnT>
+                    <a:lnB w="6350">
+                      <a:solidFill>
+                        <a:srgbClr val="D9DEE3"/>
+                      </a:solidFill>
+                    </a:lnB>
+                    <a:solidFill>
+                      <a:srgbClr val="FFFFFF"/>
+                    </a:solidFill>
+                  </a:tcPr>
+                </a:tc>
+                <a:tc>
+                  <a:txBody>
+                    <a:bodyPr wrap="none"/>
+                    <a:lstStyle/>
+                    <a:p>
+                      <a:pPr algn="r">
+                        <a:lnSpc>
+                          <a:spcPts val="1980"/>
+                        </a:lnSpc>
+                        <a:spcBef>
+                          <a:spcPts val="0"/>
+                        </a:spcBef>
+                        <a:spcAft>
+                          <a:spcPts val="0"/>
+                        </a:spcAft>
+                        <a:defRPr sz="1800" b="0">
+                          <a:solidFill>
+                            <a:srgbClr val="17212D"/>
+                          </a:solidFill>
+                          <a:latin typeface="DejaVu Sans"/>
+                        </a:defRPr>
+                      </a:pPr>
+                      <a:r>
+                        <a:t>2020</a:t>
+                      </a:r>
+                    </a:p>
+                  </a:txBody>
+                  <a:tcPr marL="82296" marR="82296" marT="91440" marB="0" anchor="t">
+                    <a:lnL w="6350">
+                      <a:noFill/>
+                    </a:lnL>
+                    <a:lnR w="6350">
+                      <a:noFill/>
+                    </a:lnR>
+                    <a:lnT w="6350">
+                      <a:noFill/>
+                    </a:lnT>
+                    <a:lnB w="6350">
+                      <a:solidFill>
+                        <a:srgbClr val="D9DEE3"/>
+                      </a:solidFill>
+                    </a:lnB>
+                    <a:solidFill>
+                      <a:srgbClr val="FFFFFF"/>
+                    </a:solidFill>
+                  </a:tcPr>
+                </a:tc>
+              </a:tr>
+              <a:tr h="402336">
+                <a:tc>
+                  <a:txBody>
+                    <a:bodyPr wrap="none"/>
+                    <a:lstStyle/>
+                    <a:p>
+                      <a:pPr algn="l">
+                        <a:lnSpc>
+                          <a:spcPts val="1980"/>
+                        </a:lnSpc>
+                        <a:spcBef>
+                          <a:spcPts val="0"/>
+                        </a:spcBef>
+                        <a:spcAft>
+                          <a:spcPts val="0"/>
+                        </a:spcAft>
+                        <a:defRPr sz="1800" b="0">
+                          <a:solidFill>
+                            <a:srgbClr val="17212D"/>
+                          </a:solidFill>
+                          <a:latin typeface="DejaVu Sans"/>
+                        </a:defRPr>
+                      </a:pPr>
+                      <a:r>
+                        <a:t>2022</a:t>
+                      </a:r>
+                    </a:p>
+                  </a:txBody>
+                  <a:tcPr marL="82296" marR="82296" marT="91440" marB="0" anchor="t">
+                    <a:lnL w="6350">
+                      <a:noFill/>
+                    </a:lnL>
+                    <a:lnR w="6350">
+                      <a:noFill/>
+                    </a:lnR>
+                    <a:lnT w="6350">
+                      <a:noFill/>
+                    </a:lnT>
+                    <a:lnB w="6350">
+                      <a:solidFill>
+                        <a:srgbClr val="D9DEE3"/>
+                      </a:solidFill>
+                    </a:lnB>
+                    <a:solidFill>
+                      <a:srgbClr val="FFFFFF"/>
+                    </a:solidFill>
+                  </a:tcPr>
+                </a:tc>
+                <a:tc>
+                  <a:txBody>
+                    <a:bodyPr wrap="none"/>
+                    <a:lstStyle/>
+                    <a:p>
+                      <a:pPr algn="r">
+                        <a:lnSpc>
+                          <a:spcPts val="1980"/>
+                        </a:lnSpc>
+                        <a:spcBef>
+                          <a:spcPts val="0"/>
+                        </a:spcBef>
+                        <a:spcAft>
+                          <a:spcPts val="0"/>
+                        </a:spcAft>
+                        <a:defRPr sz="1800" b="0">
+                          <a:solidFill>
+                            <a:srgbClr val="17212D"/>
+                          </a:solidFill>
+                          <a:latin typeface="DejaVu Sans"/>
+                        </a:defRPr>
+                      </a:pPr>
+                      <a:r>
+                        <a:t>0.000261</a:t>
+                      </a:r>
+                    </a:p>
+                  </a:txBody>
+                  <a:tcPr marL="82296" marR="82296" marT="91440" marB="0" anchor="t">
+                    <a:lnL w="6350">
+                      <a:noFill/>
+                    </a:lnL>
+                    <a:lnR w="6350">
+                      <a:noFill/>
+                    </a:lnR>
+                    <a:lnT w="6350">
+                      <a:noFill/>
+                    </a:lnT>
+                    <a:lnB w="6350">
+                      <a:solidFill>
+                        <a:srgbClr val="D9DEE3"/>
+                      </a:solidFill>
+                    </a:lnB>
+                    <a:solidFill>
+                      <a:srgbClr val="FFFFFF"/>
+                    </a:solidFill>
+                  </a:tcPr>
+                </a:tc>
+                <a:tc>
+                  <a:txBody>
+                    <a:bodyPr wrap="none"/>
+                    <a:lstStyle/>
+                    <a:p>
+                      <a:pPr algn="r">
+                        <a:lnSpc>
+                          <a:spcPts val="1980"/>
+                        </a:lnSpc>
+                        <a:spcBef>
+                          <a:spcPts val="0"/>
+                        </a:spcBef>
+                        <a:spcAft>
+                          <a:spcPts val="0"/>
+                        </a:spcAft>
+                        <a:defRPr sz="1800" b="0">
+                          <a:solidFill>
+                            <a:srgbClr val="17212D"/>
+                          </a:solidFill>
+                          <a:latin typeface="DejaVu Sans"/>
+                        </a:defRPr>
+                      </a:pPr>
+                      <a:r>
+                        <a:t>7</a:t>
+                      </a:r>
+                    </a:p>
+                  </a:txBody>
+                  <a:tcPr marL="82296" marR="82296" marT="91440" marB="0" anchor="t">
+                    <a:lnL w="6350">
+                      <a:noFill/>
+                    </a:lnL>
+                    <a:lnR w="6350">
+                      <a:noFill/>
+                    </a:lnR>
+                    <a:lnT w="6350">
+                      <a:noFill/>
+                    </a:lnT>
+                    <a:lnB w="6350">
+                      <a:solidFill>
+                        <a:srgbClr val="D9DEE3"/>
+                      </a:solidFill>
+                    </a:lnB>
+                    <a:solidFill>
+                      <a:srgbClr val="FFFFFF"/>
+                    </a:solidFill>
+                  </a:tcPr>
+                </a:tc>
+                <a:tc>
+                  <a:txBody>
+                    <a:bodyPr wrap="none"/>
+                    <a:lstStyle/>
+                    <a:p>
+                      <a:pPr algn="r">
+                        <a:lnSpc>
+                          <a:spcPts val="1980"/>
+                        </a:lnSpc>
+                        <a:spcBef>
+                          <a:spcPts val="0"/>
+                        </a:spcBef>
+                        <a:spcAft>
+                          <a:spcPts val="0"/>
+                        </a:spcAft>
+                        <a:defRPr sz="1800" b="0">
+                          <a:solidFill>
+                            <a:srgbClr val="17212D"/>
+                          </a:solidFill>
+                          <a:latin typeface="DejaVu Sans"/>
+                        </a:defRPr>
+                      </a:pPr>
+                      <a:r>
+                        <a:t>2021</a:t>
+                      </a:r>
+                    </a:p>
+                  </a:txBody>
+                  <a:tcPr marL="82296" marR="82296" marT="91440" marB="0" anchor="t">
+                    <a:lnL w="6350">
+                      <a:noFill/>
+                    </a:lnL>
+                    <a:lnR w="6350">
+                      <a:noFill/>
+                    </a:lnR>
+                    <a:lnT w="6350">
+                      <a:noFill/>
+                    </a:lnT>
+                    <a:lnB w="6350">
+                      <a:solidFill>
+                        <a:srgbClr val="D9DEE3"/>
+                      </a:solidFill>
+                    </a:lnB>
+                    <a:solidFill>
+                      <a:srgbClr val="FFFFFF"/>
+                    </a:solidFill>
+                  </a:tcPr>
+                </a:tc>
+              </a:tr>
+              <a:tr h="402336">
+                <a:tc>
+                  <a:txBody>
+                    <a:bodyPr wrap="none"/>
+                    <a:lstStyle/>
+                    <a:p>
+                      <a:pPr algn="l">
+                        <a:lnSpc>
+                          <a:spcPts val="1980"/>
+                        </a:lnSpc>
+                        <a:spcBef>
+                          <a:spcPts val="0"/>
+                        </a:spcBef>
+                        <a:spcAft>
+                          <a:spcPts val="0"/>
+                        </a:spcAft>
+                        <a:defRPr sz="1800" b="0">
+                          <a:solidFill>
+                            <a:srgbClr val="17212D"/>
+                          </a:solidFill>
+                          <a:latin typeface="DejaVu Sans"/>
+                        </a:defRPr>
+                      </a:pPr>
+                      <a:r>
+                        <a:t>2023</a:t>
+                      </a:r>
+                    </a:p>
+                  </a:txBody>
+                  <a:tcPr marL="82296" marR="82296" marT="91440" marB="0" anchor="t">
+                    <a:lnL w="6350">
+                      <a:noFill/>
+                    </a:lnL>
+                    <a:lnR w="6350">
+                      <a:noFill/>
+                    </a:lnR>
+                    <a:lnT w="6350">
+                      <a:noFill/>
+                    </a:lnT>
+                    <a:lnB w="6350">
+                      <a:solidFill>
+                        <a:srgbClr val="D9DEE3"/>
+                      </a:solidFill>
+                    </a:lnB>
+                    <a:solidFill>
+                      <a:srgbClr val="FFFFFF"/>
+                    </a:solidFill>
+                  </a:tcPr>
+                </a:tc>
+                <a:tc>
+                  <a:txBody>
+                    <a:bodyPr wrap="none"/>
+                    <a:lstStyle/>
+                    <a:p>
+                      <a:pPr algn="r">
+                        <a:lnSpc>
+                          <a:spcPts val="1980"/>
+                        </a:lnSpc>
+                        <a:spcBef>
+                          <a:spcPts val="0"/>
+                        </a:spcBef>
+                        <a:spcAft>
+                          <a:spcPts val="0"/>
+                        </a:spcAft>
+                        <a:defRPr sz="1800" b="0">
+                          <a:solidFill>
+                            <a:srgbClr val="17212D"/>
+                          </a:solidFill>
+                          <a:latin typeface="DejaVu Sans"/>
+                        </a:defRPr>
+                      </a:pPr>
+                      <a:r>
+                        <a:t>1.29e-09</a:t>
+                      </a:r>
+                    </a:p>
+                  </a:txBody>
+                  <a:tcPr marL="82296" marR="82296" marT="91440" marB="0" anchor="t">
+                    <a:lnL w="6350">
+                      <a:noFill/>
+                    </a:lnL>
+                    <a:lnR w="6350">
+                      <a:noFill/>
+                    </a:lnR>
+                    <a:lnT w="6350">
+                      <a:noFill/>
+                    </a:lnT>
+                    <a:lnB w="6350">
+                      <a:solidFill>
+                        <a:srgbClr val="D9DEE3"/>
+                      </a:solidFill>
+                    </a:lnB>
+                    <a:solidFill>
+                      <a:srgbClr val="FFFFFF"/>
+                    </a:solidFill>
+                  </a:tcPr>
+                </a:tc>
+                <a:tc>
+                  <a:txBody>
+                    <a:bodyPr wrap="none"/>
+                    <a:lstStyle/>
+                    <a:p>
+                      <a:pPr algn="r">
+                        <a:lnSpc>
+                          <a:spcPts val="1980"/>
+                        </a:lnSpc>
+                        <a:spcBef>
+                          <a:spcPts val="0"/>
+                        </a:spcBef>
+                        <a:spcAft>
+                          <a:spcPts val="0"/>
+                        </a:spcAft>
+                        <a:defRPr sz="1800" b="0">
+                          <a:solidFill>
+                            <a:srgbClr val="17212D"/>
+                          </a:solidFill>
+                          <a:latin typeface="DejaVu Sans"/>
+                        </a:defRPr>
+                      </a:pPr>
+                      <a:r>
+                        <a:t>8</a:t>
+                      </a:r>
+                    </a:p>
+                  </a:txBody>
+                  <a:tcPr marL="82296" marR="82296" marT="91440" marB="0" anchor="t">
+                    <a:lnL w="6350">
+                      <a:noFill/>
+                    </a:lnL>
+                    <a:lnR w="6350">
+                      <a:noFill/>
+                    </a:lnR>
+                    <a:lnT w="6350">
+                      <a:noFill/>
+                    </a:lnT>
+                    <a:lnB w="6350">
+                      <a:solidFill>
+                        <a:srgbClr val="D9DEE3"/>
+                      </a:solidFill>
+                    </a:lnB>
+                    <a:solidFill>
+                      <a:srgbClr val="FFFFFF"/>
+                    </a:solidFill>
+                  </a:tcPr>
+                </a:tc>
+                <a:tc>
+                  <a:txBody>
+                    <a:bodyPr wrap="none"/>
+                    <a:lstStyle/>
+                    <a:p>
+                      <a:pPr algn="r">
+                        <a:lnSpc>
+                          <a:spcPts val="1980"/>
+                        </a:lnSpc>
+                        <a:spcBef>
+                          <a:spcPts val="0"/>
+                        </a:spcBef>
+                        <a:spcAft>
+                          <a:spcPts val="0"/>
+                        </a:spcAft>
+                        <a:defRPr sz="1800" b="0">
+                          <a:solidFill>
+                            <a:srgbClr val="17212D"/>
+                          </a:solidFill>
+                          <a:latin typeface="DejaVu Sans"/>
+                        </a:defRPr>
+                      </a:pPr>
+                      <a:r>
+                        <a:t>2022</a:t>
+                      </a:r>
+                    </a:p>
+                  </a:txBody>
+                  <a:tcPr marL="82296" marR="82296" marT="91440" marB="0" anchor="t">
+                    <a:lnL w="6350">
+                      <a:noFill/>
+                    </a:lnL>
+                    <a:lnR w="6350">
+                      <a:noFill/>
+                    </a:lnR>
+                    <a:lnT w="6350">
+                      <a:noFill/>
+                    </a:lnT>
+                    <a:lnB w="6350">
+                      <a:solidFill>
+                        <a:srgbClr val="D9DEE3"/>
+                      </a:solidFill>
+                    </a:lnB>
+                    <a:solidFill>
+                      <a:srgbClr val="FFFFFF"/>
+                    </a:solidFill>
+                  </a:tcPr>
+                </a:tc>
+              </a:tr>
+              <a:tr h="402336">
+                <a:tc>
+                  <a:txBody>
+                    <a:bodyPr wrap="none"/>
+                    <a:lstStyle/>
+                    <a:p>
+                      <a:pPr algn="l">
+                        <a:lnSpc>
+                          <a:spcPts val="1980"/>
+                        </a:lnSpc>
+                        <a:spcBef>
+                          <a:spcPts val="0"/>
+                        </a:spcBef>
+                        <a:spcAft>
+                          <a:spcPts val="0"/>
+                        </a:spcAft>
+                        <a:defRPr sz="1800" b="0">
+                          <a:solidFill>
+                            <a:srgbClr val="17212D"/>
+                          </a:solidFill>
+                          <a:latin typeface="DejaVu Sans"/>
+                        </a:defRPr>
+                      </a:pPr>
+                      <a:r>
+                        <a:t>2024</a:t>
+                      </a:r>
+                    </a:p>
+                  </a:txBody>
+                  <a:tcPr marL="82296" marR="82296" marT="91440" marB="0" anchor="t">
+                    <a:lnL w="6350">
+                      <a:noFill/>
+                    </a:lnL>
+                    <a:lnR w="6350">
+                      <a:noFill/>
+                    </a:lnR>
+                    <a:lnT w="6350">
+                      <a:noFill/>
+                    </a:lnT>
+                    <a:lnB w="6350">
+                      <a:solidFill>
+                        <a:srgbClr val="D9DEE3"/>
+                      </a:solidFill>
+                    </a:lnB>
+                    <a:solidFill>
+                      <a:srgbClr val="FFFFFF"/>
+                    </a:solidFill>
+                  </a:tcPr>
+                </a:tc>
+                <a:tc>
+                  <a:txBody>
+                    <a:bodyPr wrap="none"/>
+                    <a:lstStyle/>
+                    <a:p>
+                      <a:pPr algn="r">
+                        <a:lnSpc>
+                          <a:spcPts val="1980"/>
+                        </a:lnSpc>
+                        <a:spcBef>
+                          <a:spcPts val="0"/>
+                        </a:spcBef>
+                        <a:spcAft>
+                          <a:spcPts val="0"/>
+                        </a:spcAft>
+                        <a:defRPr sz="1800" b="0">
+                          <a:solidFill>
+                            <a:srgbClr val="17212D"/>
+                          </a:solidFill>
+                          <a:latin typeface="DejaVu Sans"/>
+                        </a:defRPr>
+                      </a:pPr>
+                      <a:r>
+                        <a:t>0.000334</a:t>
+                      </a:r>
+                    </a:p>
+                  </a:txBody>
+                  <a:tcPr marL="82296" marR="82296" marT="91440" marB="0" anchor="t">
+                    <a:lnL w="6350">
+                      <a:noFill/>
+                    </a:lnL>
+                    <a:lnR w="6350">
+                      <a:noFill/>
+                    </a:lnR>
+                    <a:lnT w="6350">
+                      <a:noFill/>
+                    </a:lnT>
+                    <a:lnB w="6350">
+                      <a:solidFill>
+                        <a:srgbClr val="D9DEE3"/>
+                      </a:solidFill>
+                    </a:lnB>
+                    <a:solidFill>
+                      <a:srgbClr val="FFFFFF"/>
+                    </a:solidFill>
+                  </a:tcPr>
+                </a:tc>
+                <a:tc>
+                  <a:txBody>
+                    <a:bodyPr wrap="none"/>
+                    <a:lstStyle/>
+                    <a:p>
+                      <a:pPr algn="r">
+                        <a:lnSpc>
+                          <a:spcPts val="1980"/>
+                        </a:lnSpc>
+                        <a:spcBef>
+                          <a:spcPts val="0"/>
+                        </a:spcBef>
+                        <a:spcAft>
+                          <a:spcPts val="0"/>
+                        </a:spcAft>
+                        <a:defRPr sz="1800" b="0">
+                          <a:solidFill>
+                            <a:srgbClr val="17212D"/>
+                          </a:solidFill>
+                          <a:latin typeface="DejaVu Sans"/>
+                        </a:defRPr>
+                      </a:pPr>
+                      <a:r>
+                        <a:t>7</a:t>
+                      </a:r>
+                    </a:p>
+                  </a:txBody>
+                  <a:tcPr marL="82296" marR="82296" marT="91440" marB="0" anchor="t">
+                    <a:lnL w="6350">
+                      <a:noFill/>
+                    </a:lnL>
+                    <a:lnR w="6350">
+                      <a:noFill/>
+                    </a:lnR>
+                    <a:lnT w="6350">
+                      <a:noFill/>
+                    </a:lnT>
+                    <a:lnB w="6350">
+                      <a:solidFill>
+                        <a:srgbClr val="D9DEE3"/>
+                      </a:solidFill>
+                    </a:lnB>
+                    <a:solidFill>
+                      <a:srgbClr val="FFFFFF"/>
+                    </a:solidFill>
+                  </a:tcPr>
+                </a:tc>
+                <a:tc>
+                  <a:txBody>
+                    <a:bodyPr wrap="none"/>
+                    <a:lstStyle/>
+                    <a:p>
+                      <a:pPr algn="r">
+                        <a:lnSpc>
+                          <a:spcPts val="1980"/>
+                        </a:lnSpc>
+                        <a:spcBef>
+                          <a:spcPts val="0"/>
+                        </a:spcBef>
+                        <a:spcAft>
+                          <a:spcPts val="0"/>
+                        </a:spcAft>
+                        <a:defRPr sz="1800" b="0">
+                          <a:solidFill>
+                            <a:srgbClr val="17212D"/>
+                          </a:solidFill>
+                          <a:latin typeface="DejaVu Sans"/>
+                        </a:defRPr>
+                      </a:pPr>
+                      <a:r>
+                        <a:t>2023</a:t>
+                      </a:r>
+                    </a:p>
+                  </a:txBody>
+                  <a:tcPr marL="82296" marR="82296" marT="91440" marB="0" anchor="t">
+                    <a:lnL w="6350">
+                      <a:noFill/>
+                    </a:lnL>
+                    <a:lnR w="6350">
+                      <a:noFill/>
+                    </a:lnR>
+                    <a:lnT w="6350">
+                      <a:noFill/>
+                    </a:lnT>
+                    <a:lnB w="6350">
+                      <a:solidFill>
+                        <a:srgbClr val="D9DEE3"/>
+                      </a:solidFill>
+                    </a:lnB>
+                    <a:solidFill>
+                      <a:srgbClr val="FFFFFF"/>
+                    </a:solidFill>
+                  </a:tcPr>
+                </a:tc>
+              </a:tr>
+              <a:tr h="402336">
+                <a:tc>
+                  <a:txBody>
+                    <a:bodyPr wrap="none"/>
+                    <a:lstStyle/>
+                    <a:p>
+                      <a:pPr algn="l">
+                        <a:lnSpc>
+                          <a:spcPts val="1980"/>
+                        </a:lnSpc>
+                        <a:spcBef>
+                          <a:spcPts val="0"/>
+                        </a:spcBef>
+                        <a:spcAft>
+                          <a:spcPts val="0"/>
+                        </a:spcAft>
+                        <a:defRPr sz="1800" b="0">
+                          <a:solidFill>
+                            <a:srgbClr val="17212D"/>
+                          </a:solidFill>
+                          <a:latin typeface="DejaVu Sans"/>
+                        </a:defRPr>
+                      </a:pPr>
+                      <a:r>
+                        <a:t>2025</a:t>
+                      </a:r>
+                    </a:p>
+                  </a:txBody>
+                  <a:tcPr marL="82296" marR="82296" marT="91440" marB="0" anchor="t">
+                    <a:lnL w="6350">
+                      <a:noFill/>
+                    </a:lnL>
+                    <a:lnR w="6350">
+                      <a:noFill/>
+                    </a:lnR>
+                    <a:lnT w="6350">
+                      <a:noFill/>
+                    </a:lnT>
+                    <a:lnB w="6350">
+                      <a:solidFill>
+                        <a:srgbClr val="D9DEE3"/>
+                      </a:solidFill>
+                    </a:lnB>
+                    <a:solidFill>
+                      <a:srgbClr val="FFFFFF"/>
+                    </a:solidFill>
+                  </a:tcPr>
+                </a:tc>
+                <a:tc>
+                  <a:txBody>
+                    <a:bodyPr wrap="none"/>
+                    <a:lstStyle/>
+                    <a:p>
+                      <a:pPr algn="r">
+                        <a:lnSpc>
+                          <a:spcPts val="1980"/>
+                        </a:lnSpc>
+                        <a:spcBef>
+                          <a:spcPts val="0"/>
+                        </a:spcBef>
+                        <a:spcAft>
+                          <a:spcPts val="0"/>
+                        </a:spcAft>
+                        <a:defRPr sz="1800" b="0">
+                          <a:solidFill>
+                            <a:srgbClr val="17212D"/>
+                          </a:solidFill>
+                          <a:latin typeface="DejaVu Sans"/>
+                        </a:defRPr>
+                      </a:pPr>
+                      <a:r>
+                        <a:t>1.15e-09</a:t>
+                      </a:r>
+                    </a:p>
+                  </a:txBody>
+                  <a:tcPr marL="82296" marR="82296" marT="91440" marB="0" anchor="t">
+                    <a:lnL w="6350">
+                      <a:noFill/>
+                    </a:lnL>
+                    <a:lnR w="6350">
+                      <a:noFill/>
+                    </a:lnR>
+                    <a:lnT w="6350">
+                      <a:noFill/>
+                    </a:lnT>
+                    <a:lnB w="6350">
+                      <a:solidFill>
+                        <a:srgbClr val="D9DEE3"/>
+                      </a:solidFill>
+                    </a:lnB>
+                    <a:solidFill>
+                      <a:srgbClr val="FFFFFF"/>
+                    </a:solidFill>
+                  </a:tcPr>
+                </a:tc>
+                <a:tc>
+                  <a:txBody>
+                    <a:bodyPr wrap="none"/>
+                    <a:lstStyle/>
+                    <a:p>
+                      <a:pPr algn="r">
+                        <a:lnSpc>
+                          <a:spcPts val="1980"/>
+                        </a:lnSpc>
+                        <a:spcBef>
+                          <a:spcPts val="0"/>
+                        </a:spcBef>
+                        <a:spcAft>
+                          <a:spcPts val="0"/>
+                        </a:spcAft>
+                        <a:defRPr sz="1800" b="0">
+                          <a:solidFill>
+                            <a:srgbClr val="17212D"/>
+                          </a:solidFill>
+                          <a:latin typeface="DejaVu Sans"/>
+                        </a:defRPr>
+                      </a:pPr>
+                      <a:r>
+                        <a:t>8</a:t>
+                      </a:r>
+                    </a:p>
+                  </a:txBody>
+                  <a:tcPr marL="82296" marR="82296" marT="91440" marB="0" anchor="t">
+                    <a:lnL w="6350">
+                      <a:noFill/>
+                    </a:lnL>
+                    <a:lnR w="6350">
+                      <a:noFill/>
+                    </a:lnR>
+                    <a:lnT w="6350">
+                      <a:noFill/>
+                    </a:lnT>
+                    <a:lnB w="6350">
+                      <a:solidFill>
+                        <a:srgbClr val="D9DEE3"/>
+                      </a:solidFill>
+                    </a:lnB>
+                    <a:solidFill>
+                      <a:srgbClr val="FFFFFF"/>
+                    </a:solidFill>
+                  </a:tcPr>
+                </a:tc>
+                <a:tc>
+                  <a:txBody>
+                    <a:bodyPr wrap="none"/>
+                    <a:lstStyle/>
+                    <a:p>
+                      <a:pPr algn="r">
+                        <a:lnSpc>
+                          <a:spcPts val="1980"/>
+                        </a:lnSpc>
+                        <a:spcBef>
+                          <a:spcPts val="0"/>
+                        </a:spcBef>
+                        <a:spcAft>
+                          <a:spcPts val="0"/>
+                        </a:spcAft>
+                        <a:defRPr sz="1800" b="0">
+                          <a:solidFill>
+                            <a:srgbClr val="17212D"/>
+                          </a:solidFill>
+                          <a:latin typeface="DejaVu Sans"/>
+                        </a:defRPr>
+                      </a:pPr>
+                      <a:r>
+                        <a:t>2024</a:t>
+                      </a:r>
+                    </a:p>
+                  </a:txBody>
+                  <a:tcPr marL="82296" marR="82296" marT="91440" marB="0" anchor="t">
+                    <a:lnL w="6350">
+                      <a:noFill/>
+                    </a:lnL>
+                    <a:lnR w="6350">
+                      <a:noFill/>
+                    </a:lnR>
+                    <a:lnT w="6350">
+                      <a:noFill/>
+                    </a:lnT>
+                    <a:lnB w="6350">
+                      <a:solidFill>
+                        <a:srgbClr val="D9DEE3"/>
+                      </a:solidFill>
+                    </a:lnB>
+                    <a:solidFill>
+                      <a:srgbClr val="FFFFFF"/>
+                    </a:solidFill>
+                  </a:tcPr>
+                </a:tc>
+              </a:tr>
+              <a:tr h="402336">
+                <a:tc>
+                  <a:txBody>
+                    <a:bodyPr wrap="none"/>
+                    <a:lstStyle/>
+                    <a:p>
+                      <a:pPr algn="l">
+                        <a:lnSpc>
+                          <a:spcPts val="1980"/>
+                        </a:lnSpc>
+                        <a:spcBef>
+                          <a:spcPts val="0"/>
+                        </a:spcBef>
+                        <a:spcAft>
+                          <a:spcPts val="0"/>
+                        </a:spcAft>
+                        <a:defRPr sz="1800" b="0">
+                          <a:solidFill>
+                            <a:srgbClr val="17212D"/>
+                          </a:solidFill>
+                          <a:latin typeface="DejaVu Sans"/>
+                        </a:defRPr>
+                      </a:pPr>
+                      <a:r>
+                        <a:t>2026</a:t>
+                      </a:r>
+                    </a:p>
+                  </a:txBody>
+                  <a:tcPr marL="82296" marR="82296" marT="91440" marB="0" anchor="t">
+                    <a:lnL w="6350">
+                      <a:noFill/>
+                    </a:lnL>
+                    <a:lnR w="6350">
+                      <a:noFill/>
+                    </a:lnR>
+                    <a:lnT w="6350">
+                      <a:noFill/>
+                    </a:lnT>
+                    <a:lnB w="6350">
+                      <a:solidFill>
+                        <a:srgbClr val="D9DEE3"/>
+                      </a:solidFill>
+                    </a:lnB>
+                    <a:solidFill>
+                      <a:srgbClr val="FFFFFF"/>
+                    </a:solidFill>
+                  </a:tcPr>
+                </a:tc>
+                <a:tc>
+                  <a:txBody>
+                    <a:bodyPr wrap="none"/>
+                    <a:lstStyle/>
+                    <a:p>
+                      <a:pPr algn="r">
+                        <a:lnSpc>
+                          <a:spcPts val="1980"/>
+                        </a:lnSpc>
+                        <a:spcBef>
+                          <a:spcPts val="0"/>
+                        </a:spcBef>
+                        <a:spcAft>
+                          <a:spcPts val="0"/>
+                        </a:spcAft>
+                        <a:defRPr sz="1800" b="0">
+                          <a:solidFill>
+                            <a:srgbClr val="17212D"/>
+                          </a:solidFill>
+                          <a:latin typeface="DejaVu Sans"/>
+                        </a:defRPr>
+                      </a:pPr>
+                      <a:r>
+                        <a:t>0.000366</a:t>
+                      </a:r>
+                    </a:p>
+                  </a:txBody>
+                  <a:tcPr marL="82296" marR="82296" marT="91440" marB="0" anchor="t">
+                    <a:lnL w="6350">
+                      <a:noFill/>
+                    </a:lnL>
+                    <a:lnR w="6350">
+                      <a:noFill/>
+                    </a:lnR>
+                    <a:lnT w="6350">
+                      <a:noFill/>
+                    </a:lnT>
+                    <a:lnB w="6350">
+                      <a:solidFill>
+                        <a:srgbClr val="D9DEE3"/>
+                      </a:solidFill>
+                    </a:lnB>
+                    <a:solidFill>
+                      <a:srgbClr val="FFFFFF"/>
+                    </a:solidFill>
+                  </a:tcPr>
+                </a:tc>
+                <a:tc>
+                  <a:txBody>
+                    <a:bodyPr wrap="none"/>
+                    <a:lstStyle/>
+                    <a:p>
+                      <a:pPr algn="r">
+                        <a:lnSpc>
+                          <a:spcPts val="1980"/>
+                        </a:lnSpc>
+                        <a:spcBef>
+                          <a:spcPts val="0"/>
+                        </a:spcBef>
+                        <a:spcAft>
+                          <a:spcPts val="0"/>
+                        </a:spcAft>
+                        <a:defRPr sz="1800" b="0">
+                          <a:solidFill>
+                            <a:srgbClr val="17212D"/>
+                          </a:solidFill>
+                          <a:latin typeface="DejaVu Sans"/>
+                        </a:defRPr>
+                      </a:pPr>
+                      <a:r>
+                        <a:t>6</a:t>
+                      </a:r>
+                    </a:p>
+                  </a:txBody>
+                  <a:tcPr marL="82296" marR="82296" marT="91440" marB="0" anchor="t">
+                    <a:lnL w="6350">
+                      <a:noFill/>
+                    </a:lnL>
+                    <a:lnR w="6350">
+                      <a:noFill/>
+                    </a:lnR>
+                    <a:lnT w="6350">
+                      <a:noFill/>
+                    </a:lnT>
+                    <a:lnB w="6350">
+                      <a:solidFill>
+                        <a:srgbClr val="D9DEE3"/>
+                      </a:solidFill>
+                    </a:lnB>
+                    <a:solidFill>
+                      <a:srgbClr val="FFFFFF"/>
+                    </a:solidFill>
+                  </a:tcPr>
+                </a:tc>
+                <a:tc>
+                  <a:txBody>
+                    <a:bodyPr wrap="none"/>
+                    <a:lstStyle/>
+                    <a:p>
+                      <a:pPr algn="r">
+                        <a:lnSpc>
+                          <a:spcPts val="1980"/>
+                        </a:lnSpc>
+                        <a:spcBef>
+                          <a:spcPts val="0"/>
+                        </a:spcBef>
+                        <a:spcAft>
+                          <a:spcPts val="0"/>
+                        </a:spcAft>
+                        <a:defRPr sz="1800" b="0">
+                          <a:solidFill>
+                            <a:srgbClr val="17212D"/>
+                          </a:solidFill>
+                          <a:latin typeface="DejaVu Sans"/>
+                        </a:defRPr>
+                      </a:pPr>
+                      <a:r>
+                        <a:t>2025</a:t>
+                      </a:r>
+                    </a:p>
+                  </a:txBody>
+                  <a:tcPr marL="82296" marR="82296" marT="91440" marB="0" anchor="t">
+                    <a:lnL w="6350">
+                      <a:noFill/>
+                    </a:lnL>
+                    <a:lnR w="6350">
+                      <a:noFill/>
+                    </a:lnR>
+                    <a:lnT w="6350">
+                      <a:noFill/>
+                    </a:lnT>
+                    <a:lnB w="6350">
+                      <a:solidFill>
+                        <a:srgbClr val="D9DEE3"/>
+                      </a:solidFill>
+                    </a:lnB>
+                    <a:solidFill>
+                      <a:srgbClr val="FFFFFF"/>
+                    </a:solidFill>
+                  </a:tcPr>
+                </a:tc>
+              </a:tr>
+            </a:tbl>
+          </a:graphicData>
+        </a:graphic>
+      </p:graphicFrame>
       <p:sp>
         <p:nvSpPr>
           <p:cNvPr id="5" name="TextBox 4"/>
@@ -7690,8 +9024,8 @@
         </p:nvSpPr>
         <p:spPr>
           <a:xfrm>
-            <a:off x="896112" y="5879592"/>
-            <a:ext cx="10378440" cy="566928"/>
+            <a:off x="896112" y="4828032"/>
+            <a:ext cx="10378440" cy="502920"/>
           </a:xfrm>
           <a:prstGeom prst="rect">
             <a:avLst/>
@@ -7706,7 +9040,7 @@
           <a:p>
             <a:pPr algn="l">
               <a:lnSpc>
-                <a:spcPts val="2240"/>
+                <a:spcPts val="2464"/>
               </a:lnSpc>
               <a:spcBef>
                 <a:spcPts val="0"/>
@@ -7714,7 +9048,7 @@
               <a:spcAft>
                 <a:spcPts val="0"/>
               </a:spcAft>
-              <a:defRPr sz="2000" b="0">
+              <a:defRPr sz="2200" b="1">
                 <a:solidFill>
                   <a:srgbClr val="17212D"/>
                 </a:solidFill>
@@ -7722,7 +9056,7 @@
               </a:defRPr>
             </a:pPr>
             <a:r>
-              <a:t>Daily doubled-slippage is a daily control; smoothing and cadence are separate.</a:t>
+              <a:t>Net return: 2021–2025 96.10%; 2026 7.52%.</a:t>
             </a:r>
           </a:p>
         </p:txBody>
@@ -7730,6 +9064,51 @@
       <p:sp>
         <p:nvSpPr>
           <p:cNvPr id="6" name="TextBox 5"/>
+          <p:cNvSpPr txBox="1"/>
+          <p:nvPr/>
+        </p:nvSpPr>
+        <p:spPr>
+          <a:xfrm>
+            <a:off x="896112" y="5605272"/>
+            <a:ext cx="10378440" cy="594360"/>
+          </a:xfrm>
+          <a:prstGeom prst="rect">
+            <a:avLst/>
+          </a:prstGeom>
+          <a:noFill/>
+        </p:spPr>
+        <p:txBody>
+          <a:bodyPr wrap="none" tIns="0" bIns="0" lIns="0" rIns="0" anchor="t">
+            <a:spAutoFit/>
+          </a:bodyPr>
+          <a:lstStyle/>
+          <a:p>
+            <a:pPr algn="l">
+              <a:lnSpc>
+                <a:spcPts val="2128"/>
+              </a:lnSpc>
+              <a:spcBef>
+                <a:spcPts val="0"/>
+              </a:spcBef>
+              <a:spcAft>
+                <a:spcPts val="0"/>
+              </a:spcAft>
+              <a:defRPr sz="1900" b="0">
+                <a:solidFill>
+                  <a:srgbClr val="17212D"/>
+                </a:solidFill>
+                <a:latin typeface="DejaVu Sans"/>
+              </a:defRPr>
+            </a:pPr>
+            <a:r>
+              <a:t>2021 selects cash; weak penalties in 2023/2025 approach unpenalized regression.</a:t>
+            </a:r>
+          </a:p>
+        </p:txBody>
+      </p:sp>
+      <p:sp>
+        <p:nvSpPr>
+          <p:cNvPr id="7" name="TextBox 6"/>
           <p:cNvSpPr txBox="1"/>
           <p:nvPr/>
         </p:nvSpPr>
@@ -7883,7 +9262,7 @@
               </a:defRPr>
             </a:pPr>
             <a:r>
-              <a:t>All four methods and the matched pool; 2026 ends on 29 Apr 2026</a:t>
+              <a:t>All five methods and the matched pool; 2026 ends on 29 Apr 2026</a:t>
             </a:r>
           </a:p>
         </p:txBody>
@@ -8167,8 +9546,8 @@
           <p:nvPr/>
         </p:nvGraphicFramePr>
         <p:xfrm>
-          <a:off x="777240" y="3035808"/>
-          <a:ext cx="10607040" cy="2688336"/>
+          <a:off x="777240" y="2926080"/>
+          <a:ext cx="10607040" cy="2880360"/>
         </p:xfrm>
         <a:graphic>
           <a:graphicData uri="http://schemas.openxmlformats.org/drawingml/2006/table">
@@ -8182,7 +9561,7 @@
                 <a:gridCol w="2377440"/>
                 <a:gridCol w="2560320"/>
               </a:tblGrid>
-              <a:tr h="448056">
+              <a:tr h="411480">
                 <a:tc>
                   <a:txBody>
                     <a:bodyPr wrap="none"/>
@@ -8372,7 +9751,7 @@
                   </a:tcPr>
                 </a:tc>
               </a:tr>
-              <a:tr h="448056">
+              <a:tr h="411480">
                 <a:tc>
                   <a:txBody>
                     <a:bodyPr wrap="none"/>
@@ -8562,7 +9941,7 @@
                   </a:tcPr>
                 </a:tc>
               </a:tr>
-              <a:tr h="448056">
+              <a:tr h="411480">
                 <a:tc>
                   <a:txBody>
                     <a:bodyPr wrap="none"/>
@@ -8752,7 +10131,7 @@
                   </a:tcPr>
                 </a:tc>
               </a:tr>
-              <a:tr h="448056">
+              <a:tr h="411480">
                 <a:tc>
                   <a:txBody>
                     <a:bodyPr wrap="none"/>
@@ -8942,7 +10321,197 @@
                   </a:tcPr>
                 </a:tc>
               </a:tr>
-              <a:tr h="448056">
+              <a:tr h="411480">
+                <a:tc>
+                  <a:txBody>
+                    <a:bodyPr wrap="none"/>
+                    <a:lstStyle/>
+                    <a:p>
+                      <a:pPr algn="l">
+                        <a:lnSpc>
+                          <a:spcPts val="1980"/>
+                        </a:lnSpc>
+                        <a:spcBef>
+                          <a:spcPts val="0"/>
+                        </a:spcBef>
+                        <a:spcAft>
+                          <a:spcPts val="0"/>
+                        </a:spcAft>
+                        <a:defRPr sz="1800" b="0">
+                          <a:solidFill>
+                            <a:srgbClr val="17212D"/>
+                          </a:solidFill>
+                          <a:latin typeface="DejaVu Sans"/>
+                        </a:defRPr>
+                      </a:pPr>
+                      <a:r>
+                        <a:t>Lasso</a:t>
+                      </a:r>
+                    </a:p>
+                  </a:txBody>
+                  <a:tcPr marL="82296" marR="82296" marT="91440" marB="0" anchor="t">
+                    <a:lnL w="6350">
+                      <a:noFill/>
+                    </a:lnL>
+                    <a:lnR w="6350">
+                      <a:noFill/>
+                    </a:lnR>
+                    <a:lnT w="6350">
+                      <a:noFill/>
+                    </a:lnT>
+                    <a:lnB w="6350">
+                      <a:solidFill>
+                        <a:srgbClr val="D9DEE3"/>
+                      </a:solidFill>
+                    </a:lnB>
+                    <a:solidFill>
+                      <a:srgbClr val="FFFFFF"/>
+                    </a:solidFill>
+                  </a:tcPr>
+                </a:tc>
+                <a:tc>
+                  <a:txBody>
+                    <a:bodyPr wrap="none"/>
+                    <a:lstStyle/>
+                    <a:p>
+                      <a:pPr algn="r">
+                        <a:lnSpc>
+                          <a:spcPts val="1980"/>
+                        </a:lnSpc>
+                        <a:spcBef>
+                          <a:spcPts val="0"/>
+                        </a:spcBef>
+                        <a:spcAft>
+                          <a:spcPts val="0"/>
+                        </a:spcAft>
+                        <a:defRPr sz="1800" b="0">
+                          <a:solidFill>
+                            <a:srgbClr val="17212D"/>
+                          </a:solidFill>
+                          <a:latin typeface="DejaVu Sans"/>
+                        </a:defRPr>
+                      </a:pPr>
+                      <a:r>
+                        <a:t>96.10%</a:t>
+                      </a:r>
+                    </a:p>
+                  </a:txBody>
+                  <a:tcPr marL="82296" marR="82296" marT="91440" marB="0" anchor="t">
+                    <a:lnL w="6350">
+                      <a:noFill/>
+                    </a:lnL>
+                    <a:lnR w="6350">
+                      <a:noFill/>
+                    </a:lnR>
+                    <a:lnT w="6350">
+                      <a:noFill/>
+                    </a:lnT>
+                    <a:lnB w="6350">
+                      <a:solidFill>
+                        <a:srgbClr val="D9DEE3"/>
+                      </a:solidFill>
+                    </a:lnB>
+                    <a:solidFill>
+                      <a:srgbClr val="FFFFFF"/>
+                    </a:solidFill>
+                  </a:tcPr>
+                </a:tc>
+                <a:tc>
+                  <a:txBody>
+                    <a:bodyPr wrap="none"/>
+                    <a:lstStyle/>
+                    <a:p>
+                      <a:pPr algn="r">
+                        <a:lnSpc>
+                          <a:spcPts val="1980"/>
+                        </a:lnSpc>
+                        <a:spcBef>
+                          <a:spcPts val="0"/>
+                        </a:spcBef>
+                        <a:spcAft>
+                          <a:spcPts val="0"/>
+                        </a:spcAft>
+                        <a:defRPr sz="1800" b="0">
+                          <a:solidFill>
+                            <a:srgbClr val="17212D"/>
+                          </a:solidFill>
+                          <a:latin typeface="DejaVu Sans"/>
+                        </a:defRPr>
+                      </a:pPr>
+                      <a:r>
+                        <a:t>7.52%</a:t>
+                      </a:r>
+                    </a:p>
+                  </a:txBody>
+                  <a:tcPr marL="82296" marR="82296" marT="91440" marB="0" anchor="t">
+                    <a:lnL w="6350">
+                      <a:noFill/>
+                    </a:lnL>
+                    <a:lnR w="6350">
+                      <a:noFill/>
+                    </a:lnR>
+                    <a:lnT w="6350">
+                      <a:noFill/>
+                    </a:lnT>
+                    <a:lnB w="6350">
+                      <a:solidFill>
+                        <a:srgbClr val="D9DEE3"/>
+                      </a:solidFill>
+                    </a:lnB>
+                    <a:solidFill>
+                      <a:srgbClr val="FFFFFF"/>
+                    </a:solidFill>
+                  </a:tcPr>
+                </a:tc>
+                <a:tc>
+                  <a:txBody>
+                    <a:bodyPr wrap="none"/>
+                    <a:lstStyle/>
+                    <a:p>
+                      <a:pPr algn="r">
+                        <a:lnSpc>
+                          <a:spcPts val="1980"/>
+                        </a:lnSpc>
+                        <a:spcBef>
+                          <a:spcPts val="0"/>
+                        </a:spcBef>
+                        <a:spcAft>
+                          <a:spcPts val="0"/>
+                        </a:spcAft>
+                        <a:defRPr sz="1800" b="0">
+                          <a:solidFill>
+                            <a:srgbClr val="17212D"/>
+                          </a:solidFill>
+                          <a:latin typeface="DejaVu Sans"/>
+                        </a:defRPr>
+                      </a:pPr>
+                      <a:r>
+                        <a:t>-0.65</a:t>
+                      </a:r>
+                    </a:p>
+                  </a:txBody>
+                  <a:tcPr marL="82296" marR="82296" marT="91440" marB="0" anchor="t">
+                    <a:lnL w="6350">
+                      <a:noFill/>
+                    </a:lnL>
+                    <a:lnR w="6350">
+                      <a:noFill/>
+                    </a:lnR>
+                    <a:lnT w="6350">
+                      <a:noFill/>
+                    </a:lnT>
+                    <a:lnB w="6350">
+                      <a:solidFill>
+                        <a:srgbClr val="D9DEE3"/>
+                      </a:solidFill>
+                    </a:lnB>
+                    <a:solidFill>
+                      <a:srgbClr val="FFFFFF"/>
+                    </a:solidFill>
+                  </a:tcPr>
+                </a:tc>
+              </a:tr>
+              <a:tr h="411480">
                 <a:tc>
                   <a:txBody>
                     <a:bodyPr wrap="none"/>
@@ -9132,7 +10701,7 @@
                   </a:tcPr>
                 </a:tc>
               </a:tr>
-              <a:tr h="448056">
+              <a:tr h="411480">
                 <a:tc>
                   <a:txBody>
                     <a:bodyPr wrap="none"/>
@@ -9366,7 +10935,7 @@
               </a:defRPr>
             </a:pPr>
             <a:r>
-              <a:t>The latest-year excess is modest, with mixed results across methods.</a:t>
+              <a:t>Lasso trails Ridge in both evaluation intervals; 2021 selects cash.</a:t>
             </a:r>
           </a:p>
         </p:txBody>
@@ -9617,11 +11186,7 @@
               </a:defRPr>
             </a:pPr>
             <a:r>
-              <a:t>2 2026: Ridge excess +0.56 pp; methods and score cohorts give</a:t>
-            </a:r>
-            <a:br/>
-            <a:r>
-              <a:t>mixed results.</a:t>
+              <a:t>2 Lasso trails Ridge: 2021–2025 96.10%; 2026 7.52% net.</a:t>
             </a:r>
           </a:p>
         </p:txBody>
@@ -11910,7 +13475,7 @@
         </p:nvGraphicFramePr>
         <p:xfrm>
           <a:off x="777240" y="2852928"/>
-          <a:ext cx="10607040" cy="2514600"/>
+          <a:ext cx="10607040" cy="2743200"/>
         </p:xfrm>
         <a:graphic>
           <a:graphicData uri="http://schemas.openxmlformats.org/drawingml/2006/table">
@@ -11923,7 +13488,7 @@
                 <a:gridCol w="5486400"/>
                 <a:gridCol w="2651760"/>
               </a:tblGrid>
-              <a:tr h="502920">
+              <a:tr h="457200">
                 <a:tc>
                   <a:txBody>
                     <a:bodyPr wrap="none"/>
@@ -12066,7 +13631,7 @@
                   </a:tcPr>
                 </a:tc>
               </a:tr>
-              <a:tr h="502920">
+              <a:tr h="457200">
                 <a:tc>
                   <a:txBody>
                     <a:bodyPr wrap="none"/>
@@ -12209,7 +13774,7 @@
                   </a:tcPr>
                 </a:tc>
               </a:tr>
-              <a:tr h="502920">
+              <a:tr h="457200">
                 <a:tc>
                   <a:txBody>
                     <a:bodyPr wrap="none"/>
@@ -12352,7 +13917,7 @@
                   </a:tcPr>
                 </a:tc>
               </a:tr>
-              <a:tr h="502920">
+              <a:tr h="457200">
                 <a:tc>
                   <a:txBody>
                     <a:bodyPr wrap="none"/>
@@ -12495,7 +14060,150 @@
                   </a:tcPr>
                 </a:tc>
               </a:tr>
-              <a:tr h="502920">
+              <a:tr h="457200">
+                <a:tc>
+                  <a:txBody>
+                    <a:bodyPr wrap="none"/>
+                    <a:lstStyle/>
+                    <a:p>
+                      <a:pPr algn="l">
+                        <a:lnSpc>
+                          <a:spcPts val="1980"/>
+                        </a:lnSpc>
+                        <a:spcBef>
+                          <a:spcPts val="0"/>
+                        </a:spcBef>
+                        <a:spcAft>
+                          <a:spcPts val="0"/>
+                        </a:spcAft>
+                        <a:defRPr sz="1800" b="0">
+                          <a:solidFill>
+                            <a:srgbClr val="17212D"/>
+                          </a:solidFill>
+                          <a:latin typeface="DejaVu Sans"/>
+                        </a:defRPr>
+                      </a:pPr>
+                      <a:r>
+                        <a:t>Lasso</a:t>
+                      </a:r>
+                    </a:p>
+                  </a:txBody>
+                  <a:tcPr marL="82296" marR="82296" marT="91440" marB="0" anchor="t">
+                    <a:lnL w="6350">
+                      <a:noFill/>
+                    </a:lnL>
+                    <a:lnR w="6350">
+                      <a:noFill/>
+                    </a:lnR>
+                    <a:lnT w="6350">
+                      <a:noFill/>
+                    </a:lnT>
+                    <a:lnB w="6350">
+                      <a:solidFill>
+                        <a:srgbClr val="D9DEE3"/>
+                      </a:solidFill>
+                    </a:lnB>
+                    <a:solidFill>
+                      <a:srgbClr val="FFFFFF"/>
+                    </a:solidFill>
+                  </a:tcPr>
+                </a:tc>
+                <a:tc>
+                  <a:txBody>
+                    <a:bodyPr wrap="none"/>
+                    <a:lstStyle/>
+                    <a:p>
+                      <a:pPr algn="l">
+                        <a:lnSpc>
+                          <a:spcPts val="1980"/>
+                        </a:lnSpc>
+                        <a:spcBef>
+                          <a:spcPts val="0"/>
+                        </a:spcBef>
+                        <a:spcAft>
+                          <a:spcPts val="0"/>
+                        </a:spcAft>
+                        <a:defRPr sz="1800" b="0">
+                          <a:solidFill>
+                            <a:srgbClr val="17212D"/>
+                          </a:solidFill>
+                          <a:latin typeface="DejaVu Sans"/>
+                        </a:defRPr>
+                      </a:pPr>
+                      <a:r>
+                        <a:t>Historical time-validation alpha</a:t>
+                      </a:r>
+                    </a:p>
+                  </a:txBody>
+                  <a:tcPr marL="82296" marR="82296" marT="91440" marB="0" anchor="t">
+                    <a:lnL w="6350">
+                      <a:noFill/>
+                    </a:lnL>
+                    <a:lnR w="6350">
+                      <a:noFill/>
+                    </a:lnR>
+                    <a:lnT w="6350">
+                      <a:noFill/>
+                    </a:lnT>
+                    <a:lnB w="6350">
+                      <a:solidFill>
+                        <a:srgbClr val="D9DEE3"/>
+                      </a:solidFill>
+                    </a:lnB>
+                    <a:solidFill>
+                      <a:srgbClr val="FFFFFF"/>
+                    </a:solidFill>
+                  </a:tcPr>
+                </a:tc>
+                <a:tc>
+                  <a:txBody>
+                    <a:bodyPr wrap="none"/>
+                    <a:lstStyle/>
+                    <a:p>
+                      <a:pPr algn="r">
+                        <a:lnSpc>
+                          <a:spcPts val="1980"/>
+                        </a:lnSpc>
+                        <a:spcBef>
+                          <a:spcPts val="0"/>
+                        </a:spcBef>
+                        <a:spcAft>
+                          <a:spcPts val="0"/>
+                        </a:spcAft>
+                        <a:defRPr sz="1800" b="0">
+                          <a:solidFill>
+                            <a:srgbClr val="17212D"/>
+                          </a:solidFill>
+                          <a:latin typeface="DejaVu Sans"/>
+                        </a:defRPr>
+                      </a:pPr>
+                      <a:r>
+                        <a:t>20</a:t>
+                      </a:r>
+                    </a:p>
+                  </a:txBody>
+                  <a:tcPr marL="82296" marR="82296" marT="91440" marB="0" anchor="t">
+                    <a:lnL w="6350">
+                      <a:noFill/>
+                    </a:lnL>
+                    <a:lnR w="6350">
+                      <a:noFill/>
+                    </a:lnR>
+                    <a:lnT w="6350">
+                      <a:noFill/>
+                    </a:lnT>
+                    <a:lnB w="6350">
+                      <a:solidFill>
+                        <a:srgbClr val="D9DEE3"/>
+                      </a:solidFill>
+                    </a:lnB>
+                    <a:solidFill>
+                      <a:srgbClr val="FFFFFF"/>
+                    </a:solidFill>
+                  </a:tcPr>
+                </a:tc>
+              </a:tr>
+              <a:tr h="457200">
                 <a:tc>
                   <a:txBody>
                     <a:bodyPr wrap="none"/>
@@ -13639,7 +15347,7 @@
               </a:defRPr>
             </a:pPr>
             <a:r>
-              <a:t>All four methods and the equal-weight pool are shown over the full history.</a:t>
+              <a:t>All five methods and the equal-weight pool are shown over the full history.</a:t>
             </a:r>
           </a:p>
         </p:txBody>

</xml_diff>

<commit_message>
Keep Lasso in the common Top100 ranking strategy
</commit_message>
<xml_diff>
--- a/Presentation_Group9.pptx
+++ b/Presentation_Group9.pptx
@@ -1224,7 +1224,7 @@
           <a:lstStyle/>
           <a:p>
             <a:r>
-              <a:t>Suggested speaking time: 65 seconds. Explain the L1 versus L2 comparison using the displayed annual sparse coefficient counts and matched returns. For each year, internal training labels exit before previous-calendar-year validation starts; validation labels exit before the forecast year. Compare 15 alpha fractions with equal-date mean validation MSE, then refit on all mature history. The alpha scale is not Ridge's alpha scale. State whether sparsity actually occurs: Lasso may retain every input. An all-zero annual fit emits no score, so the next scheduled target requests cash subject to blocked-sale constraints; there is no arbitrary code-order Top-100 ranking. Prediction loss and fee-paying Top-100 returns are different objectives. The already reviewed 2026 history is not a new blind test.</a:t>
+              <a:t>Suggested speaking time: 65 seconds. Explain the L1 versus L2 comparison using the displayed annual sparse coefficient counts and matched returns. For each year, internal training labels exit before previous-calendar-year validation starts; validation labels exit before the forecast year. Compare 15 alpha fractions with equal-date mean validation MSE, then refit on all mature history. The alpha scale is not Ridge's alpha scale. State whether sparsity actually occurs: Lasso may retain every input. Null and constant-ranking candidates are retained only as validation diagnostics; only rankable candidates can be selected for the original Top-100 strategy, and the final refit must remain nonconstant. Prediction loss and fee-paying Top-100 returns are different objectives. The already reviewed 2026 history is not a new blind test.</a:t>
             </a:r>
           </a:p>
         </p:txBody>
@@ -1294,7 +1294,7 @@
           <a:lstStyle/>
           <a:p>
             <a:r>
-              <a:t>Suggested speaking time: 70 seconds. Read every method, including Lasso: its 2021–2025 net return is 96.10%, and its 2026 net return is 7.52%. Ridge remains the original reference implementation. Compare net returns and summed daily excess separately. Absolute returns compound; excess sums daily differences.</a:t>
+              <a:t>Suggested speaking time: 70 seconds. Read every method, including Lasso: its 2021–2025 net return is 128.45%, and its 2026 net return is 7.52%. Ridge remains the original reference implementation. Compare net returns and summed daily excess separately. Absolute returns compound; excess sums daily differences.</a:t>
             </a:r>
           </a:p>
         </p:txBody>
@@ -7943,7 +7943,7 @@
                         </a:defRPr>
                       </a:pPr>
                       <a:r>
-                        <a:t>0.00114</a:t>
+                        <a:t>0.00102</a:t>
                       </a:r>
                     </a:p>
                   </a:txBody>
@@ -7990,7 +7990,7 @@
                         </a:defRPr>
                       </a:pPr>
                       <a:r>
-                        <a:t>0</a:t>
+                        <a:t>1</a:t>
                       </a:r>
                     </a:p>
                   </a:txBody>
@@ -9056,7 +9056,7 @@
               </a:defRPr>
             </a:pPr>
             <a:r>
-              <a:t>Net return: 2021–2025 96.10%; 2026 7.52%.</a:t>
+              <a:t>Net return: 2021–2025 128.45%; 2026 7.52%.</a:t>
             </a:r>
           </a:p>
         </p:txBody>
@@ -9101,7 +9101,7 @@
               </a:defRPr>
             </a:pPr>
             <a:r>
-              <a:t>2021 selects cash; weak penalties in 2023/2025 approach unpenalized regression.</a:t>
+              <a:t>Null fits remain diagnostics; rankable models follow the original Top-100 rule.</a:t>
             </a:r>
           </a:p>
         </p:txBody>
@@ -10392,7 +10392,7 @@
                         </a:defRPr>
                       </a:pPr>
                       <a:r>
-                        <a:t>96.10%</a:t>
+                        <a:t>128.45%</a:t>
                       </a:r>
                     </a:p>
                   </a:txBody>
@@ -10935,7 +10935,7 @@
               </a:defRPr>
             </a:pPr>
             <a:r>
-              <a:t>Lasso trails Ridge in both evaluation intervals; 2021 selects cash.</a:t>
+              <a:t>Lasso trails Ridge in both evaluation intervals.</a:t>
             </a:r>
           </a:p>
         </p:txBody>
@@ -11186,7 +11186,7 @@
               </a:defRPr>
             </a:pPr>
             <a:r>
-              <a:t>2 Lasso trails Ridge: 2021–2025 96.10%; 2026 7.52% net.</a:t>
+              <a:t>2 Lasso: 2021–2025 128.45%; 2026 7.52% net.</a:t>
             </a:r>
           </a:p>
         </p:txBody>

</xml_diff>

<commit_message>
Optimize Lasso with development-only rolling validation
</commit_message>
<xml_diff>
--- a/Presentation_Group9.pptx
+++ b/Presentation_Group9.pptx
@@ -1224,7 +1224,7 @@
           <a:lstStyle/>
           <a:p>
             <a:r>
-              <a:t>Suggested speaking time: 65 seconds. Explain the L1 versus L2 comparison using the displayed annual sparse coefficient counts and matched returns. For each year, internal training labels exit before previous-calendar-year validation starts; validation labels exit before the forecast year. Compare 15 alpha fractions with equal-date mean validation MSE, then refit on all mature history. The alpha scale is not Ridge's alpha scale. State whether sparsity actually occurs: Lasso may retain every input. Null and constant-ranking candidates are retained only as validation diagnostics; only rankable candidates can be selected for the original Top-100 strategy, and the final refit must remain nonconstant. Prediction loss and fee-paying Top-100 returns are different objectives. The already reviewed 2026 history is not a new blind test.</a:t>
+              <a:t>Suggested speaking time: 65 seconds. Explain the frozen Lasso: 8 inputs, 3-year rolling history, demeaned return target, EMA20. Inner alpha selection maximizes mean daily Rank IC over 15 fractions. Internal training exits precede prior-calendar-year validation; validation exits precede each forecast year. Only rankable fits can enter the same Top-100 strategy. Outer selection compares 96 Lasso configurations and 48 paired Ridge controls on 2021–2025 net results, with paired inputs, window, target and EMA. Paired Ridge uses fixed alpha10,000 and a float64 Gram solver; its penalty is not separately tuned. Original methods remain frozen; development gains do not prove L1 superiority. 2026 is evaluated only after the specification is frozen, and its already reviewed history is not a new blind test. Coefficient sparsity, prediction quality and net portfolio returns are different measurements.</a:t>
             </a:r>
           </a:p>
         </p:txBody>
@@ -1294,7 +1294,7 @@
           <a:lstStyle/>
           <a:p>
             <a:r>
-              <a:t>Suggested speaking time: 70 seconds. Read every method, including Lasso: its 2021–2025 net return is 128.45%, and its 2026 net return is 7.52%. Ridge remains the original reference implementation. Compare net returns and summed daily excess separately. Absolute returns compound; excess sums daily differences.</a:t>
+              <a:t>Suggested speaking time: 70 seconds. Read every method, including Lasso: its 2021–2025 net return is 211.46%, and its 2026 net return is 3.35%. Ridge remains the original reference implementation. Compare net returns and summed daily excess separately. Absolute returns compound; excess sums daily differences.</a:t>
             </a:r>
           </a:p>
         </p:txBody>
@@ -1434,7 +1434,7 @@
           <a:lstStyle/>
           <a:p>
             <a:r>
-              <a:t>Suggested speaking time: 0 seconds. Appendix for questions; no main-presentation time allocated. The matrix covers the union of twelve used annual model inputs, averaging same-date cross-sectional Spearman matrices over 243 sampled development dates. It is not a covariance matrix of strategy returns and not an independent test of alpha.</a:t>
+              <a:t>Suggested speaking time: 0 seconds. Appendix for questions; no main-presentation time allocated. The matrix covers the displayed union of used annual model inputs, averaging same-date cross-sectional Spearman matrices over the sampled development dates. It is not a covariance matrix of strategy returns and not an independent test of alpha.</a:t>
             </a:r>
           </a:p>
         </p:txBody>
@@ -7653,7 +7653,7 @@
               </a:defRPr>
             </a:pPr>
             <a:r>
-              <a:t>Same eight inputs, EMA20 and execution as Ridge; L1 rather than L2 penalty</a:t>
+              <a:t>8 inputs · 3-year rolling history · demeaned return target · EMA20</a:t>
             </a:r>
           </a:p>
         </p:txBody>
@@ -7943,7 +7943,7 @@
                         </a:defRPr>
                       </a:pPr>
                       <a:r>
-                        <a:t>0.00102</a:t>
+                        <a:t>3.41e-05</a:t>
                       </a:r>
                     </a:p>
                   </a:txBody>
@@ -7990,7 +7990,7 @@
                         </a:defRPr>
                       </a:pPr>
                       <a:r>
-                        <a:t>1</a:t>
+                        <a:t>7</a:t>
                       </a:r>
                     </a:p>
                   </a:txBody>
@@ -8133,7 +8133,7 @@
                         </a:defRPr>
                       </a:pPr>
                       <a:r>
-                        <a:t>0.000261</a:t>
+                        <a:t>0.000199</a:t>
                       </a:r>
                     </a:p>
                   </a:txBody>
@@ -8180,7 +8180,7 @@
                         </a:defRPr>
                       </a:pPr>
                       <a:r>
-                        <a:t>7</a:t>
+                        <a:t>8</a:t>
                       </a:r>
                     </a:p>
                   </a:txBody>
@@ -8323,7 +8323,7 @@
                         </a:defRPr>
                       </a:pPr>
                       <a:r>
-                        <a:t>1.29e-09</a:t>
+                        <a:t>1.47e-09</a:t>
                       </a:r>
                     </a:p>
                   </a:txBody>
@@ -8513,7 +8513,7 @@
                         </a:defRPr>
                       </a:pPr>
                       <a:r>
-                        <a:t>0.000334</a:t>
+                        <a:t>0.000455</a:t>
                       </a:r>
                     </a:p>
                   </a:txBody>
@@ -8560,7 +8560,7 @@
                         </a:defRPr>
                       </a:pPr>
                       <a:r>
-                        <a:t>7</a:t>
+                        <a:t>4</a:t>
                       </a:r>
                     </a:p>
                   </a:txBody>
@@ -8703,7 +8703,7 @@
                         </a:defRPr>
                       </a:pPr>
                       <a:r>
-                        <a:t>1.15e-09</a:t>
+                        <a:t>1.55e-09</a:t>
                       </a:r>
                     </a:p>
                   </a:txBody>
@@ -8893,7 +8893,7 @@
                         </a:defRPr>
                       </a:pPr>
                       <a:r>
-                        <a:t>0.000366</a:t>
+                        <a:t>0.000411</a:t>
                       </a:r>
                     </a:p>
                   </a:txBody>
@@ -8940,7 +8940,7 @@
                         </a:defRPr>
                       </a:pPr>
                       <a:r>
-                        <a:t>6</a:t>
+                        <a:t>4</a:t>
                       </a:r>
                     </a:p>
                   </a:txBody>
@@ -9056,7 +9056,7 @@
               </a:defRPr>
             </a:pPr>
             <a:r>
-              <a:t>Net return: 2021–2025 128.45%; 2026 7.52%.</a:t>
+              <a:t>Net return: 2021–2025 211.46%; 2026 3.35%.</a:t>
             </a:r>
           </a:p>
         </p:txBody>
@@ -9101,7 +9101,11 @@
               </a:defRPr>
             </a:pPr>
             <a:r>
-              <a:t>Null fits remain diagnostics; rankable models follow the original Top-100 rule.</a:t>
+              <a:t>144 dev tests · paired Ridge 223.12% · original Lasso 128.45%.</a:t>
+            </a:r>
+            <a:br/>
+            <a:r>
+              <a:t>2026: selected 3.35% vs original Lasso 7.52%; no reselection.</a:t>
             </a:r>
           </a:p>
         </p:txBody>
@@ -10392,7 +10396,7 @@
                         </a:defRPr>
                       </a:pPr>
                       <a:r>
-                        <a:t>128.45%</a:t>
+                        <a:t>211.46%</a:t>
                       </a:r>
                     </a:p>
                   </a:txBody>
@@ -10439,7 +10443,7 @@
                         </a:defRPr>
                       </a:pPr>
                       <a:r>
-                        <a:t>7.52%</a:t>
+                        <a:t>3.35%</a:t>
                       </a:r>
                     </a:p>
                   </a:txBody>
@@ -10486,7 +10490,7 @@
                         </a:defRPr>
                       </a:pPr>
                       <a:r>
-                        <a:t>-0.65</a:t>
+                        <a:t>-4.48</a:t>
                       </a:r>
                     </a:p>
                   </a:txBody>
@@ -10935,7 +10939,7 @@
               </a:defRPr>
             </a:pPr>
             <a:r>
-              <a:t>Lasso trails Ridge in both evaluation intervals.</a:t>
+              <a:t>Lasso improves development return; 2026 trails original Ridge.</a:t>
             </a:r>
           </a:p>
         </p:txBody>
@@ -11186,7 +11190,7 @@
               </a:defRPr>
             </a:pPr>
             <a:r>
-              <a:t>2 Lasso: 2021–2025 128.45%; 2026 7.52% net.</a:t>
+              <a:t>2 Lasso: 2021–2025 211.46%; 2026 3.35% net.</a:t>
             </a:r>
           </a:p>
         </p:txBody>
@@ -12309,7 +12313,7 @@
               </a:defRPr>
             </a:pPr>
             <a:r>
-              <a:t>Fourteen candidate inputs; twelve inputs used across the fixed annual models</a:t>
+              <a:t>Fourteen candidate inputs; 12 used across the frozen models</a:t>
             </a:r>
           </a:p>
         </p:txBody>
@@ -14131,7 +14135,7 @@
                         </a:defRPr>
                       </a:pPr>
                       <a:r>
-                        <a:t>Historical time-validation alpha</a:t>
+                        <a:t>L1; 8 inputs; annual validation alpha</a:t>
                       </a:r>
                     </a:p>
                   </a:txBody>

</xml_diff>

<commit_message>
Align primary model versions and periods across deliverables
</commit_message>
<xml_diff>
--- a/Presentation_Group9.pptx
+++ b/Presentation_Group9.pptx
@@ -1224,7 +1224,7 @@
           <a:lstStyle/>
           <a:p>
             <a:r>
-              <a:t>Suggested speaking time: 65 seconds. Explain the frozen Lasso: 8 inputs, 3-year rolling history, demeaned return target, EMA20. Inner alpha selection maximizes mean daily Rank IC over 15 fractions. Internal training exits precede prior-calendar-year validation; validation exits precede each forecast year. Only rankable fits can enter the same Top-100 strategy. Outer selection compares 96 Lasso configurations and 48 paired Ridge controls on 2021–2025 net results, with paired inputs, window, target and EMA. Paired Ridge uses fixed alpha10,000 and a float64 Gram solver; its penalty is not separately tuned. Original methods remain frozen; development gains do not prove L1 superiority. 2026 is evaluated only after the specification is frozen, and its already reviewed history is not a new blind test. Coefficient sparsity, prediction quality and net portfolio returns are different measurements.</a:t>
+              <a:t>Suggested speaking time: 65 seconds. Explain the frozen Lasso: 8 inputs, 3-year rolling history, demeaned return target, EMA20. Inner alpha selection maximizes mean daily Rank IC over 15 fractions. Internal training exits precede prior-calendar-year validation; validation exits precede each forecast year. Only rankable fits can enter the same Top-100 strategy. Outer selection compares 96 Lasso configurations and 48 paired Ridge controls on 2021–2025 net results, with paired inputs, window, target and EMA. Ridge-3y control uses fixed alpha10,000 and a float64 Gram solver; its penalty is not separately tuned. Original methods remain frozen; development gains do not prove L1 superiority. 2026 is evaluated only after the specification is frozen, and its already reviewed history is not a new blind test. Coefficient sparsity, prediction quality and net portfolio returns are different measurements.</a:t>
             </a:r>
           </a:p>
         </p:txBody>
@@ -1294,7 +1294,7 @@
           <a:lstStyle/>
           <a:p>
             <a:r>
-              <a:t>Suggested speaking time: 70 seconds. Read every method, including Lasso: its 2021–2025 net return is 211.46%, and its 2026 net return is 3.35%. Ridge remains the original reference implementation. Compare net returns and summed daily excess separately. Absolute returns compound; excess sums daily differences.</a:t>
+              <a:t>Suggested speaking time: 70 seconds. Read the same two published models across all three periods: full Lasso-3y 417.56%, Ridge-exp 395.35%; development 211.46% versus 195.66%; 2026 3.35% versus 8.80%. Full history includes fitted replay. These are not different model versions. The auxiliary Ridge-3y control is a development diagnostic and is not the main Ridge-exp curve.</a:t>
             </a:r>
           </a:p>
         </p:txBody>
@@ -5534,7 +5534,7 @@
               </a:defRPr>
             </a:pPr>
             <a:r>
-              <a:t>Ridge's 2026 daily net excess is +0.56 pp through 29 Apr 2026.</a:t>
+              <a:t>Full net excess: Lasso-3y +66.64 pp; Ridge-exp +63.82 pp.</a:t>
             </a:r>
           </a:p>
         </p:txBody>
@@ -5695,7 +5695,7 @@
               </a:defRPr>
             </a:pPr>
             <a:r>
-              <a:t>Full-history drawdown and 2021–2025 net return / volatility</a:t>
+              <a:t>Same published versions · Full-history drawdown; 2021–2025 return / volatility</a:t>
             </a:r>
           </a:p>
         </p:txBody>
@@ -5878,7 +5878,7 @@
               </a:defRPr>
             </a:pPr>
             <a:r>
-              <a:t>Ridge max. drawdown: -33.0%; pool: -32.4%.</a:t>
+              <a:t>Risk scatter: Ridge-exp versus Lasso-3y; auxiliary Ridge-3y control is not plotted.</a:t>
             </a:r>
           </a:p>
         </p:txBody>
@@ -6039,7 +6039,7 @@
               </a:defRPr>
             </a:pPr>
             <a:r>
-              <a:t>Ridge · Sum of daily net differences within each month, in pp</a:t>
+              <a:t>Ridge-exp · Sum of daily net differences within each month, in pp</a:t>
             </a:r>
           </a:p>
         </p:txBody>
@@ -6269,7 +6269,7 @@
               </a:defRPr>
             </a:pPr>
             <a:r>
-              <a:t>Ridge and the matched pool · Compounded within each calendar year</a:t>
+              <a:t>Ridge-exp and the matched pool · Compounded within each calendar year</a:t>
             </a:r>
           </a:p>
         </p:txBody>
@@ -7608,7 +7608,7 @@
               </a:defRPr>
             </a:pPr>
             <a:r>
-              <a:t>Lasso: sparse model, matched experiment</a:t>
+              <a:t>Lasso-3y: sparse model, matched experiment</a:t>
             </a:r>
           </a:p>
         </p:txBody>
@@ -9101,7 +9101,7 @@
               </a:defRPr>
             </a:pPr>
             <a:r>
-              <a:t>144 dev tests · paired Ridge 223.12% · original Lasso 128.45%.</a:t>
+              <a:t>144 dev tests · Ridge-3y control 223.12% · original Lasso 128.45%.</a:t>
             </a:r>
             <a:br/>
             <a:r>
@@ -9221,7 +9221,7 @@
               </a:defRPr>
             </a:pPr>
             <a:r>
-              <a:t>Net performance at a glance</a:t>
+              <a:t>One comparison, three periods</a:t>
             </a:r>
           </a:p>
         </p:txBody>
@@ -9266,292 +9266,22 @@
               </a:defRPr>
             </a:pPr>
             <a:r>
-              <a:t>All five methods and the matched pool; 2026 ends on 29 Apr 2026</a:t>
-            </a:r>
-          </a:p>
-        </p:txBody>
-      </p:sp>
-      <p:sp>
-        <p:nvSpPr>
-          <p:cNvPr id="4" name="TextBox 3"/>
-          <p:cNvSpPr txBox="1"/>
-          <p:nvPr/>
-        </p:nvSpPr>
-        <p:spPr>
-          <a:xfrm>
-            <a:off x="914400" y="1773936"/>
-            <a:ext cx="3063240" cy="274320"/>
-          </a:xfrm>
-          <a:prstGeom prst="rect">
-            <a:avLst/>
-          </a:prstGeom>
-          <a:noFill/>
-        </p:spPr>
-        <p:txBody>
-          <a:bodyPr wrap="none" tIns="0" bIns="0" lIns="0" rIns="0" anchor="t">
-            <a:spAutoFit/>
-          </a:bodyPr>
-          <a:lstStyle/>
-          <a:p>
-            <a:pPr algn="l">
-              <a:lnSpc>
-                <a:spcPts val="1568"/>
-              </a:lnSpc>
-              <a:spcBef>
-                <a:spcPts val="0"/>
-              </a:spcBef>
-              <a:spcAft>
-                <a:spcPts val="0"/>
-              </a:spcAft>
-              <a:defRPr sz="1400" b="1">
-                <a:solidFill>
-                  <a:srgbClr val="68737E"/>
-                </a:solidFill>
-                <a:latin typeface="DejaVu Sans"/>
-              </a:defRPr>
-            </a:pPr>
-            <a:r>
-              <a:t>RIDGE · 2021–2025 NET</a:t>
-            </a:r>
-          </a:p>
-        </p:txBody>
-      </p:sp>
-      <p:sp>
-        <p:nvSpPr>
-          <p:cNvPr id="5" name="TextBox 4"/>
-          <p:cNvSpPr txBox="1"/>
-          <p:nvPr/>
-        </p:nvSpPr>
-        <p:spPr>
-          <a:xfrm>
-            <a:off x="914400" y="2176272"/>
-            <a:ext cx="3063240" cy="502920"/>
-          </a:xfrm>
-          <a:prstGeom prst="rect">
-            <a:avLst/>
-          </a:prstGeom>
-          <a:noFill/>
-        </p:spPr>
-        <p:txBody>
-          <a:bodyPr wrap="none" tIns="0" bIns="0" lIns="0" rIns="0" anchor="t">
-            <a:spAutoFit/>
-          </a:bodyPr>
-          <a:lstStyle/>
-          <a:p>
-            <a:pPr algn="l">
-              <a:lnSpc>
-                <a:spcPts val="3584"/>
-              </a:lnSpc>
-              <a:spcBef>
-                <a:spcPts val="0"/>
-              </a:spcBef>
-              <a:spcAft>
-                <a:spcPts val="0"/>
-              </a:spcAft>
-              <a:defRPr sz="3200" b="1">
-                <a:solidFill>
-                  <a:srgbClr val="007C83"/>
-                </a:solidFill>
-                <a:latin typeface="DejaVu Sans"/>
-              </a:defRPr>
-            </a:pPr>
-            <a:r>
-              <a:t>195.66%</a:t>
-            </a:r>
-          </a:p>
-        </p:txBody>
-      </p:sp>
-      <p:sp>
-        <p:nvSpPr>
-          <p:cNvPr id="6" name="TextBox 5"/>
-          <p:cNvSpPr txBox="1"/>
-          <p:nvPr/>
-        </p:nvSpPr>
-        <p:spPr>
-          <a:xfrm>
-            <a:off x="4572000" y="1773936"/>
-            <a:ext cx="3063240" cy="274320"/>
-          </a:xfrm>
-          <a:prstGeom prst="rect">
-            <a:avLst/>
-          </a:prstGeom>
-          <a:noFill/>
-        </p:spPr>
-        <p:txBody>
-          <a:bodyPr wrap="none" tIns="0" bIns="0" lIns="0" rIns="0" anchor="t">
-            <a:spAutoFit/>
-          </a:bodyPr>
-          <a:lstStyle/>
-          <a:p>
-            <a:pPr algn="l">
-              <a:lnSpc>
-                <a:spcPts val="1568"/>
-              </a:lnSpc>
-              <a:spcBef>
-                <a:spcPts val="0"/>
-              </a:spcBef>
-              <a:spcAft>
-                <a:spcPts val="0"/>
-              </a:spcAft>
-              <a:defRPr sz="1400" b="1">
-                <a:solidFill>
-                  <a:srgbClr val="68737E"/>
-                </a:solidFill>
-                <a:latin typeface="DejaVu Sans"/>
-              </a:defRPr>
-            </a:pPr>
-            <a:r>
-              <a:t>RIDGE · 2026 NET</a:t>
-            </a:r>
-          </a:p>
-        </p:txBody>
-      </p:sp>
-      <p:sp>
-        <p:nvSpPr>
-          <p:cNvPr id="7" name="TextBox 6"/>
-          <p:cNvSpPr txBox="1"/>
-          <p:nvPr/>
-        </p:nvSpPr>
-        <p:spPr>
-          <a:xfrm>
-            <a:off x="4572000" y="2176272"/>
-            <a:ext cx="3063240" cy="502920"/>
-          </a:xfrm>
-          <a:prstGeom prst="rect">
-            <a:avLst/>
-          </a:prstGeom>
-          <a:noFill/>
-        </p:spPr>
-        <p:txBody>
-          <a:bodyPr wrap="none" tIns="0" bIns="0" lIns="0" rIns="0" anchor="t">
-            <a:spAutoFit/>
-          </a:bodyPr>
-          <a:lstStyle/>
-          <a:p>
-            <a:pPr algn="l">
-              <a:lnSpc>
-                <a:spcPts val="3584"/>
-              </a:lnSpc>
-              <a:spcBef>
-                <a:spcPts val="0"/>
-              </a:spcBef>
-              <a:spcAft>
-                <a:spcPts val="0"/>
-              </a:spcAft>
-              <a:defRPr sz="3200" b="1">
-                <a:solidFill>
-                  <a:srgbClr val="007C83"/>
-                </a:solidFill>
-                <a:latin typeface="DejaVu Sans"/>
-              </a:defRPr>
-            </a:pPr>
-            <a:r>
-              <a:t>8.80%</a:t>
-            </a:r>
-          </a:p>
-        </p:txBody>
-      </p:sp>
-      <p:sp>
-        <p:nvSpPr>
-          <p:cNvPr id="8" name="TextBox 7"/>
-          <p:cNvSpPr txBox="1"/>
-          <p:nvPr/>
-        </p:nvSpPr>
-        <p:spPr>
-          <a:xfrm>
-            <a:off x="8229600" y="1773936"/>
-            <a:ext cx="3063240" cy="274320"/>
-          </a:xfrm>
-          <a:prstGeom prst="rect">
-            <a:avLst/>
-          </a:prstGeom>
-          <a:noFill/>
-        </p:spPr>
-        <p:txBody>
-          <a:bodyPr wrap="none" tIns="0" bIns="0" lIns="0" rIns="0" anchor="t">
-            <a:spAutoFit/>
-          </a:bodyPr>
-          <a:lstStyle/>
-          <a:p>
-            <a:pPr algn="l">
-              <a:lnSpc>
-                <a:spcPts val="1568"/>
-              </a:lnSpc>
-              <a:spcBef>
-                <a:spcPts val="0"/>
-              </a:spcBef>
-              <a:spcAft>
-                <a:spcPts val="0"/>
-              </a:spcAft>
-              <a:defRPr sz="1400" b="1">
-                <a:solidFill>
-                  <a:srgbClr val="68737E"/>
-                </a:solidFill>
-                <a:latin typeface="DejaVu Sans"/>
-              </a:defRPr>
-            </a:pPr>
-            <a:r>
-              <a:t>RIDGE · 2026 EXCESS</a:t>
-            </a:r>
-          </a:p>
-        </p:txBody>
-      </p:sp>
-      <p:sp>
-        <p:nvSpPr>
-          <p:cNvPr id="9" name="TextBox 8"/>
-          <p:cNvSpPr txBox="1"/>
-          <p:nvPr/>
-        </p:nvSpPr>
-        <p:spPr>
-          <a:xfrm>
-            <a:off x="8229600" y="2176272"/>
-            <a:ext cx="3063240" cy="502920"/>
-          </a:xfrm>
-          <a:prstGeom prst="rect">
-            <a:avLst/>
-          </a:prstGeom>
-          <a:noFill/>
-        </p:spPr>
-        <p:txBody>
-          <a:bodyPr wrap="none" tIns="0" bIns="0" lIns="0" rIns="0" anchor="t">
-            <a:spAutoFit/>
-          </a:bodyPr>
-          <a:lstStyle/>
-          <a:p>
-            <a:pPr algn="l">
-              <a:lnSpc>
-                <a:spcPts val="3584"/>
-              </a:lnSpc>
-              <a:spcBef>
-                <a:spcPts val="0"/>
-              </a:spcBef>
-              <a:spcAft>
-                <a:spcPts val="0"/>
-              </a:spcAft>
-              <a:defRPr sz="3200" b="1">
-                <a:solidFill>
-                  <a:srgbClr val="007C83"/>
-                </a:solidFill>
-                <a:latin typeface="DejaVu Sans"/>
-              </a:defRPr>
-            </a:pPr>
-            <a:r>
-              <a:t>+0.56 pp</a:t>
+              <a:t>The same published model versions in the tables, curves and conclusions</a:t>
             </a:r>
           </a:p>
         </p:txBody>
       </p:sp>
       <p:graphicFrame>
         <p:nvGraphicFramePr>
-          <p:cNvPr id="10" name="Table 9"/>
+          <p:cNvPr id="4" name="Table 3"/>
           <p:cNvGraphicFramePr>
             <a:graphicFrameLocks noGrp="1"/>
           </p:cNvGraphicFramePr>
           <p:nvPr/>
         </p:nvGraphicFramePr>
         <p:xfrm>
-          <a:off x="777240" y="2926080"/>
-          <a:ext cx="10607040" cy="2880360"/>
+          <a:off x="777240" y="1883664"/>
+          <a:ext cx="10607040" cy="1810512"/>
         </p:xfrm>
         <a:graphic>
           <a:graphicData uri="http://schemas.openxmlformats.org/drawingml/2006/table">
@@ -9561,11 +9291,11 @@
               </a:tblPr>
               <a:tblGrid>
                 <a:gridCol w="2743200"/>
-                <a:gridCol w="2926080"/>
-                <a:gridCol w="2377440"/>
                 <a:gridCol w="2560320"/>
+                <a:gridCol w="2651760"/>
+                <a:gridCol w="2651760"/>
               </a:tblGrid>
-              <a:tr h="411480">
+              <a:tr h="603504">
                 <a:tc>
                   <a:txBody>
                     <a:bodyPr wrap="none"/>
@@ -9573,7 +9303,7 @@
                     <a:p>
                       <a:pPr algn="l">
                         <a:lnSpc>
-                          <a:spcPts val="1980"/>
+                          <a:spcPts val="2530"/>
                         </a:lnSpc>
                         <a:spcBef>
                           <a:spcPts val="0"/>
@@ -9581,7 +9311,7 @@
                         <a:spcAft>
                           <a:spcPts val="0"/>
                         </a:spcAft>
-                        <a:defRPr sz="1800" b="1">
+                        <a:defRPr sz="2300" b="1">
                           <a:solidFill>
                             <a:srgbClr val="17212D"/>
                           </a:solidFill>
@@ -9589,7 +9319,7 @@
                         </a:defRPr>
                       </a:pPr>
                       <a:r>
-                        <a:t>Method</a:t>
+                        <a:t>Model version</a:t>
                       </a:r>
                     </a:p>
                   </a:txBody>
@@ -9620,7 +9350,7 @@
                     <a:p>
                       <a:pPr algn="r">
                         <a:lnSpc>
-                          <a:spcPts val="1980"/>
+                          <a:spcPts val="2530"/>
                         </a:lnSpc>
                         <a:spcBef>
                           <a:spcPts val="0"/>
@@ -9628,7 +9358,7 @@
                         <a:spcAft>
                           <a:spcPts val="0"/>
                         </a:spcAft>
-                        <a:defRPr sz="1800" b="1">
+                        <a:defRPr sz="2300" b="1">
                           <a:solidFill>
                             <a:srgbClr val="17212D"/>
                           </a:solidFill>
@@ -9636,7 +9366,7 @@
                         </a:defRPr>
                       </a:pPr>
                       <a:r>
-                        <a:t>2021–2025 net</a:t>
+                        <a:t>Full net</a:t>
                       </a:r>
                     </a:p>
                   </a:txBody>
@@ -9667,7 +9397,7 @@
                     <a:p>
                       <a:pPr algn="r">
                         <a:lnSpc>
-                          <a:spcPts val="1980"/>
+                          <a:spcPts val="2530"/>
                         </a:lnSpc>
                         <a:spcBef>
                           <a:spcPts val="0"/>
@@ -9675,7 +9405,7 @@
                         <a:spcAft>
                           <a:spcPts val="0"/>
                         </a:spcAft>
-                        <a:defRPr sz="1800" b="1">
+                        <a:defRPr sz="2300" b="1">
                           <a:solidFill>
                             <a:srgbClr val="17212D"/>
                           </a:solidFill>
@@ -9683,7 +9413,7 @@
                         </a:defRPr>
                       </a:pPr>
                       <a:r>
-                        <a:t>2026 net</a:t>
+                        <a:t>2021–2025 net</a:t>
                       </a:r>
                     </a:p>
                   </a:txBody>
@@ -9714,7 +9444,7 @@
                     <a:p>
                       <a:pPr algn="r">
                         <a:lnSpc>
-                          <a:spcPts val="1980"/>
+                          <a:spcPts val="2530"/>
                         </a:lnSpc>
                         <a:spcBef>
                           <a:spcPts val="0"/>
@@ -9722,7 +9452,7 @@
                         <a:spcAft>
                           <a:spcPts val="0"/>
                         </a:spcAft>
-                        <a:defRPr sz="1800" b="1">
+                        <a:defRPr sz="2300" b="1">
                           <a:solidFill>
                             <a:srgbClr val="17212D"/>
                           </a:solidFill>
@@ -9730,7 +9460,7 @@
                         </a:defRPr>
                       </a:pPr>
                       <a:r>
-                        <a:t>2026 excess (pp)</a:t>
+                        <a:t>2026 net</a:t>
                       </a:r>
                     </a:p>
                   </a:txBody>
@@ -9755,7 +9485,7 @@
                   </a:tcPr>
                 </a:tc>
               </a:tr>
-              <a:tr h="411480">
+              <a:tr h="603504">
                 <a:tc>
                   <a:txBody>
                     <a:bodyPr wrap="none"/>
@@ -9763,7 +9493,7 @@
                     <a:p>
                       <a:pPr algn="l">
                         <a:lnSpc>
-                          <a:spcPts val="1980"/>
+                          <a:spcPts val="2530"/>
                         </a:lnSpc>
                         <a:spcBef>
                           <a:spcPts val="0"/>
@@ -9771,7 +9501,7 @@
                         <a:spcAft>
                           <a:spcPts val="0"/>
                         </a:spcAft>
-                        <a:defRPr sz="1800" b="0">
+                        <a:defRPr sz="2300" b="0">
                           <a:solidFill>
                             <a:srgbClr val="17212D"/>
                           </a:solidFill>
@@ -9779,7 +9509,7 @@
                         </a:defRPr>
                       </a:pPr>
                       <a:r>
-                        <a:t>Fundamental</a:t>
+                        <a:t>Ridge-exp</a:t>
                       </a:r>
                     </a:p>
                   </a:txBody>
@@ -9810,7 +9540,7 @@
                     <a:p>
                       <a:pPr algn="r">
                         <a:lnSpc>
-                          <a:spcPts val="1980"/>
+                          <a:spcPts val="2530"/>
                         </a:lnSpc>
                         <a:spcBef>
                           <a:spcPts val="0"/>
@@ -9818,7 +9548,7 @@
                         <a:spcAft>
                           <a:spcPts val="0"/>
                         </a:spcAft>
-                        <a:defRPr sz="1800" b="0">
+                        <a:defRPr sz="2300" b="0">
                           <a:solidFill>
                             <a:srgbClr val="17212D"/>
                           </a:solidFill>
@@ -9826,7 +9556,7 @@
                         </a:defRPr>
                       </a:pPr>
                       <a:r>
-                        <a:t>139.90%</a:t>
+                        <a:t>395.35%</a:t>
                       </a:r>
                     </a:p>
                   </a:txBody>
@@ -9857,7 +9587,7 @@
                     <a:p>
                       <a:pPr algn="r">
                         <a:lnSpc>
-                          <a:spcPts val="1980"/>
+                          <a:spcPts val="2530"/>
                         </a:lnSpc>
                         <a:spcBef>
                           <a:spcPts val="0"/>
@@ -9865,7 +9595,7 @@
                         <a:spcAft>
                           <a:spcPts val="0"/>
                         </a:spcAft>
-                        <a:defRPr sz="1800" b="0">
+                        <a:defRPr sz="2300" b="0">
                           <a:solidFill>
                             <a:srgbClr val="17212D"/>
                           </a:solidFill>
@@ -9873,7 +9603,7 @@
                         </a:defRPr>
                       </a:pPr>
                       <a:r>
-                        <a:t>3.53%</a:t>
+                        <a:t>195.66%</a:t>
                       </a:r>
                     </a:p>
                   </a:txBody>
@@ -9904,7 +9634,7 @@
                     <a:p>
                       <a:pPr algn="r">
                         <a:lnSpc>
-                          <a:spcPts val="1980"/>
+                          <a:spcPts val="2530"/>
                         </a:lnSpc>
                         <a:spcBef>
                           <a:spcPts val="0"/>
@@ -9912,7 +9642,7 @@
                         <a:spcAft>
                           <a:spcPts val="0"/>
                         </a:spcAft>
-                        <a:defRPr sz="1800" b="0">
+                        <a:defRPr sz="2300" b="0">
                           <a:solidFill>
                             <a:srgbClr val="17212D"/>
                           </a:solidFill>
@@ -9920,7 +9650,7 @@
                         </a:defRPr>
                       </a:pPr>
                       <a:r>
-                        <a:t>-4.25</a:t>
+                        <a:t>8.80%</a:t>
                       </a:r>
                     </a:p>
                   </a:txBody>
@@ -9945,7 +9675,7 @@
                   </a:tcPr>
                 </a:tc>
               </a:tr>
-              <a:tr h="411480">
+              <a:tr h="603504">
                 <a:tc>
                   <a:txBody>
                     <a:bodyPr wrap="none"/>
@@ -9953,7 +9683,7 @@
                     <a:p>
                       <a:pPr algn="l">
                         <a:lnSpc>
-                          <a:spcPts val="1980"/>
+                          <a:spcPts val="2530"/>
                         </a:lnSpc>
                         <a:spcBef>
                           <a:spcPts val="0"/>
@@ -9961,7 +9691,7 @@
                         <a:spcAft>
                           <a:spcPts val="0"/>
                         </a:spcAft>
-                        <a:defRPr sz="1800" b="0">
+                        <a:defRPr sz="2300" b="0">
                           <a:solidFill>
                             <a:srgbClr val="17212D"/>
                           </a:solidFill>
@@ -9969,7 +9699,7 @@
                         </a:defRPr>
                       </a:pPr>
                       <a:r>
-                        <a:t>Combined</a:t>
+                        <a:t>Lasso-3y</a:t>
                       </a:r>
                     </a:p>
                   </a:txBody>
@@ -10000,7 +9730,7 @@
                     <a:p>
                       <a:pPr algn="r">
                         <a:lnSpc>
-                          <a:spcPts val="1980"/>
+                          <a:spcPts val="2530"/>
                         </a:lnSpc>
                         <a:spcBef>
                           <a:spcPts val="0"/>
@@ -10008,7 +9738,7 @@
                         <a:spcAft>
                           <a:spcPts val="0"/>
                         </a:spcAft>
-                        <a:defRPr sz="1800" b="0">
+                        <a:defRPr sz="2300" b="0">
                           <a:solidFill>
                             <a:srgbClr val="17212D"/>
                           </a:solidFill>
@@ -10016,7 +9746,7 @@
                         </a:defRPr>
                       </a:pPr>
                       <a:r>
-                        <a:t>145.46%</a:t>
+                        <a:t>417.56%</a:t>
                       </a:r>
                     </a:p>
                   </a:txBody>
@@ -10047,7 +9777,7 @@
                     <a:p>
                       <a:pPr algn="r">
                         <a:lnSpc>
-                          <a:spcPts val="1980"/>
+                          <a:spcPts val="2530"/>
                         </a:lnSpc>
                         <a:spcBef>
                           <a:spcPts val="0"/>
@@ -10055,7 +9785,7 @@
                         <a:spcAft>
                           <a:spcPts val="0"/>
                         </a:spcAft>
-                        <a:defRPr sz="1800" b="0">
+                        <a:defRPr sz="2300" b="0">
                           <a:solidFill>
                             <a:srgbClr val="17212D"/>
                           </a:solidFill>
@@ -10063,7 +9793,7 @@
                         </a:defRPr>
                       </a:pPr>
                       <a:r>
-                        <a:t>9.73%</a:t>
+                        <a:t>211.46%</a:t>
                       </a:r>
                     </a:p>
                   </a:txBody>
@@ -10094,7 +9824,7 @@
                     <a:p>
                       <a:pPr algn="r">
                         <a:lnSpc>
-                          <a:spcPts val="1980"/>
+                          <a:spcPts val="2530"/>
                         </a:lnSpc>
                         <a:spcBef>
                           <a:spcPts val="0"/>
@@ -10102,340 +9832,7 @@
                         <a:spcAft>
                           <a:spcPts val="0"/>
                         </a:spcAft>
-                        <a:defRPr sz="1800" b="0">
-                          <a:solidFill>
-                            <a:srgbClr val="17212D"/>
-                          </a:solidFill>
-                          <a:latin typeface="DejaVu Sans"/>
-                        </a:defRPr>
-                      </a:pPr>
-                      <a:r>
-                        <a:t>+1.33</a:t>
-                      </a:r>
-                    </a:p>
-                  </a:txBody>
-                  <a:tcPr marL="82296" marR="82296" marT="91440" marB="0" anchor="t">
-                    <a:lnL w="6350">
-                      <a:noFill/>
-                    </a:lnL>
-                    <a:lnR w="6350">
-                      <a:noFill/>
-                    </a:lnR>
-                    <a:lnT w="6350">
-                      <a:noFill/>
-                    </a:lnT>
-                    <a:lnB w="6350">
-                      <a:solidFill>
-                        <a:srgbClr val="D9DEE3"/>
-                      </a:solidFill>
-                    </a:lnB>
-                    <a:solidFill>
-                      <a:srgbClr val="FFFFFF"/>
-                    </a:solidFill>
-                  </a:tcPr>
-                </a:tc>
-              </a:tr>
-              <a:tr h="411480">
-                <a:tc>
-                  <a:txBody>
-                    <a:bodyPr wrap="none"/>
-                    <a:lstStyle/>
-                    <a:p>
-                      <a:pPr algn="l">
-                        <a:lnSpc>
-                          <a:spcPts val="1980"/>
-                        </a:lnSpc>
-                        <a:spcBef>
-                          <a:spcPts val="0"/>
-                        </a:spcBef>
-                        <a:spcAft>
-                          <a:spcPts val="0"/>
-                        </a:spcAft>
-                        <a:defRPr sz="1800" b="1">
-                          <a:solidFill>
-                            <a:srgbClr val="007C83"/>
-                          </a:solidFill>
-                          <a:latin typeface="DejaVu Sans"/>
-                        </a:defRPr>
-                      </a:pPr>
-                      <a:r>
-                        <a:t>Ridge</a:t>
-                      </a:r>
-                    </a:p>
-                  </a:txBody>
-                  <a:tcPr marL="82296" marR="82296" marT="91440" marB="0" anchor="t">
-                    <a:lnL w="6350">
-                      <a:noFill/>
-                    </a:lnL>
-                    <a:lnR w="6350">
-                      <a:noFill/>
-                    </a:lnR>
-                    <a:lnT w="6350">
-                      <a:noFill/>
-                    </a:lnT>
-                    <a:lnB w="6350">
-                      <a:solidFill>
-                        <a:srgbClr val="D9DEE3"/>
-                      </a:solidFill>
-                    </a:lnB>
-                    <a:solidFill>
-                      <a:srgbClr val="FFFFFF"/>
-                    </a:solidFill>
-                  </a:tcPr>
-                </a:tc>
-                <a:tc>
-                  <a:txBody>
-                    <a:bodyPr wrap="none"/>
-                    <a:lstStyle/>
-                    <a:p>
-                      <a:pPr algn="r">
-                        <a:lnSpc>
-                          <a:spcPts val="1980"/>
-                        </a:lnSpc>
-                        <a:spcBef>
-                          <a:spcPts val="0"/>
-                        </a:spcBef>
-                        <a:spcAft>
-                          <a:spcPts val="0"/>
-                        </a:spcAft>
-                        <a:defRPr sz="1800" b="1">
-                          <a:solidFill>
-                            <a:srgbClr val="007C83"/>
-                          </a:solidFill>
-                          <a:latin typeface="DejaVu Sans"/>
-                        </a:defRPr>
-                      </a:pPr>
-                      <a:r>
-                        <a:t>195.66%</a:t>
-                      </a:r>
-                    </a:p>
-                  </a:txBody>
-                  <a:tcPr marL="82296" marR="82296" marT="91440" marB="0" anchor="t">
-                    <a:lnL w="6350">
-                      <a:noFill/>
-                    </a:lnL>
-                    <a:lnR w="6350">
-                      <a:noFill/>
-                    </a:lnR>
-                    <a:lnT w="6350">
-                      <a:noFill/>
-                    </a:lnT>
-                    <a:lnB w="6350">
-                      <a:solidFill>
-                        <a:srgbClr val="D9DEE3"/>
-                      </a:solidFill>
-                    </a:lnB>
-                    <a:solidFill>
-                      <a:srgbClr val="FFFFFF"/>
-                    </a:solidFill>
-                  </a:tcPr>
-                </a:tc>
-                <a:tc>
-                  <a:txBody>
-                    <a:bodyPr wrap="none"/>
-                    <a:lstStyle/>
-                    <a:p>
-                      <a:pPr algn="r">
-                        <a:lnSpc>
-                          <a:spcPts val="1980"/>
-                        </a:lnSpc>
-                        <a:spcBef>
-                          <a:spcPts val="0"/>
-                        </a:spcBef>
-                        <a:spcAft>
-                          <a:spcPts val="0"/>
-                        </a:spcAft>
-                        <a:defRPr sz="1800" b="1">
-                          <a:solidFill>
-                            <a:srgbClr val="007C83"/>
-                          </a:solidFill>
-                          <a:latin typeface="DejaVu Sans"/>
-                        </a:defRPr>
-                      </a:pPr>
-                      <a:r>
-                        <a:t>8.80%</a:t>
-                      </a:r>
-                    </a:p>
-                  </a:txBody>
-                  <a:tcPr marL="82296" marR="82296" marT="91440" marB="0" anchor="t">
-                    <a:lnL w="6350">
-                      <a:noFill/>
-                    </a:lnL>
-                    <a:lnR w="6350">
-                      <a:noFill/>
-                    </a:lnR>
-                    <a:lnT w="6350">
-                      <a:noFill/>
-                    </a:lnT>
-                    <a:lnB w="6350">
-                      <a:solidFill>
-                        <a:srgbClr val="D9DEE3"/>
-                      </a:solidFill>
-                    </a:lnB>
-                    <a:solidFill>
-                      <a:srgbClr val="FFFFFF"/>
-                    </a:solidFill>
-                  </a:tcPr>
-                </a:tc>
-                <a:tc>
-                  <a:txBody>
-                    <a:bodyPr wrap="none"/>
-                    <a:lstStyle/>
-                    <a:p>
-                      <a:pPr algn="r">
-                        <a:lnSpc>
-                          <a:spcPts val="1980"/>
-                        </a:lnSpc>
-                        <a:spcBef>
-                          <a:spcPts val="0"/>
-                        </a:spcBef>
-                        <a:spcAft>
-                          <a:spcPts val="0"/>
-                        </a:spcAft>
-                        <a:defRPr sz="1800" b="1">
-                          <a:solidFill>
-                            <a:srgbClr val="007C83"/>
-                          </a:solidFill>
-                          <a:latin typeface="DejaVu Sans"/>
-                        </a:defRPr>
-                      </a:pPr>
-                      <a:r>
-                        <a:t>+0.56</a:t>
-                      </a:r>
-                    </a:p>
-                  </a:txBody>
-                  <a:tcPr marL="82296" marR="82296" marT="91440" marB="0" anchor="t">
-                    <a:lnL w="6350">
-                      <a:noFill/>
-                    </a:lnL>
-                    <a:lnR w="6350">
-                      <a:noFill/>
-                    </a:lnR>
-                    <a:lnT w="6350">
-                      <a:noFill/>
-                    </a:lnT>
-                    <a:lnB w="6350">
-                      <a:solidFill>
-                        <a:srgbClr val="D9DEE3"/>
-                      </a:solidFill>
-                    </a:lnB>
-                    <a:solidFill>
-                      <a:srgbClr val="FFFFFF"/>
-                    </a:solidFill>
-                  </a:tcPr>
-                </a:tc>
-              </a:tr>
-              <a:tr h="411480">
-                <a:tc>
-                  <a:txBody>
-                    <a:bodyPr wrap="none"/>
-                    <a:lstStyle/>
-                    <a:p>
-                      <a:pPr algn="l">
-                        <a:lnSpc>
-                          <a:spcPts val="1980"/>
-                        </a:lnSpc>
-                        <a:spcBef>
-                          <a:spcPts val="0"/>
-                        </a:spcBef>
-                        <a:spcAft>
-                          <a:spcPts val="0"/>
-                        </a:spcAft>
-                        <a:defRPr sz="1800" b="0">
-                          <a:solidFill>
-                            <a:srgbClr val="17212D"/>
-                          </a:solidFill>
-                          <a:latin typeface="DejaVu Sans"/>
-                        </a:defRPr>
-                      </a:pPr>
-                      <a:r>
-                        <a:t>Lasso</a:t>
-                      </a:r>
-                    </a:p>
-                  </a:txBody>
-                  <a:tcPr marL="82296" marR="82296" marT="91440" marB="0" anchor="t">
-                    <a:lnL w="6350">
-                      <a:noFill/>
-                    </a:lnL>
-                    <a:lnR w="6350">
-                      <a:noFill/>
-                    </a:lnR>
-                    <a:lnT w="6350">
-                      <a:noFill/>
-                    </a:lnT>
-                    <a:lnB w="6350">
-                      <a:solidFill>
-                        <a:srgbClr val="D9DEE3"/>
-                      </a:solidFill>
-                    </a:lnB>
-                    <a:solidFill>
-                      <a:srgbClr val="FFFFFF"/>
-                    </a:solidFill>
-                  </a:tcPr>
-                </a:tc>
-                <a:tc>
-                  <a:txBody>
-                    <a:bodyPr wrap="none"/>
-                    <a:lstStyle/>
-                    <a:p>
-                      <a:pPr algn="r">
-                        <a:lnSpc>
-                          <a:spcPts val="1980"/>
-                        </a:lnSpc>
-                        <a:spcBef>
-                          <a:spcPts val="0"/>
-                        </a:spcBef>
-                        <a:spcAft>
-                          <a:spcPts val="0"/>
-                        </a:spcAft>
-                        <a:defRPr sz="1800" b="0">
-                          <a:solidFill>
-                            <a:srgbClr val="17212D"/>
-                          </a:solidFill>
-                          <a:latin typeface="DejaVu Sans"/>
-                        </a:defRPr>
-                      </a:pPr>
-                      <a:r>
-                        <a:t>211.46%</a:t>
-                      </a:r>
-                    </a:p>
-                  </a:txBody>
-                  <a:tcPr marL="82296" marR="82296" marT="91440" marB="0" anchor="t">
-                    <a:lnL w="6350">
-                      <a:noFill/>
-                    </a:lnL>
-                    <a:lnR w="6350">
-                      <a:noFill/>
-                    </a:lnR>
-                    <a:lnT w="6350">
-                      <a:noFill/>
-                    </a:lnT>
-                    <a:lnB w="6350">
-                      <a:solidFill>
-                        <a:srgbClr val="D9DEE3"/>
-                      </a:solidFill>
-                    </a:lnB>
-                    <a:solidFill>
-                      <a:srgbClr val="FFFFFF"/>
-                    </a:solidFill>
-                  </a:tcPr>
-                </a:tc>
-                <a:tc>
-                  <a:txBody>
-                    <a:bodyPr wrap="none"/>
-                    <a:lstStyle/>
-                    <a:p>
-                      <a:pPr algn="r">
-                        <a:lnSpc>
-                          <a:spcPts val="1980"/>
-                        </a:lnSpc>
-                        <a:spcBef>
-                          <a:spcPts val="0"/>
-                        </a:spcBef>
-                        <a:spcAft>
-                          <a:spcPts val="0"/>
-                        </a:spcAft>
-                        <a:defRPr sz="1800" b="0">
+                        <a:defRPr sz="2300" b="0">
                           <a:solidFill>
                             <a:srgbClr val="17212D"/>
                           </a:solidFill>
@@ -10444,433 +9841,6 @@
                       </a:pPr>
                       <a:r>
                         <a:t>3.35%</a:t>
-                      </a:r>
-                    </a:p>
-                  </a:txBody>
-                  <a:tcPr marL="82296" marR="82296" marT="91440" marB="0" anchor="t">
-                    <a:lnL w="6350">
-                      <a:noFill/>
-                    </a:lnL>
-                    <a:lnR w="6350">
-                      <a:noFill/>
-                    </a:lnR>
-                    <a:lnT w="6350">
-                      <a:noFill/>
-                    </a:lnT>
-                    <a:lnB w="6350">
-                      <a:solidFill>
-                        <a:srgbClr val="D9DEE3"/>
-                      </a:solidFill>
-                    </a:lnB>
-                    <a:solidFill>
-                      <a:srgbClr val="FFFFFF"/>
-                    </a:solidFill>
-                  </a:tcPr>
-                </a:tc>
-                <a:tc>
-                  <a:txBody>
-                    <a:bodyPr wrap="none"/>
-                    <a:lstStyle/>
-                    <a:p>
-                      <a:pPr algn="r">
-                        <a:lnSpc>
-                          <a:spcPts val="1980"/>
-                        </a:lnSpc>
-                        <a:spcBef>
-                          <a:spcPts val="0"/>
-                        </a:spcBef>
-                        <a:spcAft>
-                          <a:spcPts val="0"/>
-                        </a:spcAft>
-                        <a:defRPr sz="1800" b="0">
-                          <a:solidFill>
-                            <a:srgbClr val="17212D"/>
-                          </a:solidFill>
-                          <a:latin typeface="DejaVu Sans"/>
-                        </a:defRPr>
-                      </a:pPr>
-                      <a:r>
-                        <a:t>-4.48</a:t>
-                      </a:r>
-                    </a:p>
-                  </a:txBody>
-                  <a:tcPr marL="82296" marR="82296" marT="91440" marB="0" anchor="t">
-                    <a:lnL w="6350">
-                      <a:noFill/>
-                    </a:lnL>
-                    <a:lnR w="6350">
-                      <a:noFill/>
-                    </a:lnR>
-                    <a:lnT w="6350">
-                      <a:noFill/>
-                    </a:lnT>
-                    <a:lnB w="6350">
-                      <a:solidFill>
-                        <a:srgbClr val="D9DEE3"/>
-                      </a:solidFill>
-                    </a:lnB>
-                    <a:solidFill>
-                      <a:srgbClr val="FFFFFF"/>
-                    </a:solidFill>
-                  </a:tcPr>
-                </a:tc>
-              </a:tr>
-              <a:tr h="411480">
-                <a:tc>
-                  <a:txBody>
-                    <a:bodyPr wrap="none"/>
-                    <a:lstStyle/>
-                    <a:p>
-                      <a:pPr algn="l">
-                        <a:lnSpc>
-                          <a:spcPts val="1980"/>
-                        </a:lnSpc>
-                        <a:spcBef>
-                          <a:spcPts val="0"/>
-                        </a:spcBef>
-                        <a:spcAft>
-                          <a:spcPts val="0"/>
-                        </a:spcAft>
-                        <a:defRPr sz="1800" b="0">
-                          <a:solidFill>
-                            <a:srgbClr val="17212D"/>
-                          </a:solidFill>
-                          <a:latin typeface="DejaVu Sans"/>
-                        </a:defRPr>
-                      </a:pPr>
-                      <a:r>
-                        <a:t>LightGBM</a:t>
-                      </a:r>
-                    </a:p>
-                  </a:txBody>
-                  <a:tcPr marL="82296" marR="82296" marT="91440" marB="0" anchor="t">
-                    <a:lnL w="6350">
-                      <a:noFill/>
-                    </a:lnL>
-                    <a:lnR w="6350">
-                      <a:noFill/>
-                    </a:lnR>
-                    <a:lnT w="6350">
-                      <a:noFill/>
-                    </a:lnT>
-                    <a:lnB w="6350">
-                      <a:solidFill>
-                        <a:srgbClr val="D9DEE3"/>
-                      </a:solidFill>
-                    </a:lnB>
-                    <a:solidFill>
-                      <a:srgbClr val="FFFFFF"/>
-                    </a:solidFill>
-                  </a:tcPr>
-                </a:tc>
-                <a:tc>
-                  <a:txBody>
-                    <a:bodyPr wrap="none"/>
-                    <a:lstStyle/>
-                    <a:p>
-                      <a:pPr algn="r">
-                        <a:lnSpc>
-                          <a:spcPts val="1980"/>
-                        </a:lnSpc>
-                        <a:spcBef>
-                          <a:spcPts val="0"/>
-                        </a:spcBef>
-                        <a:spcAft>
-                          <a:spcPts val="0"/>
-                        </a:spcAft>
-                        <a:defRPr sz="1800" b="0">
-                          <a:solidFill>
-                            <a:srgbClr val="17212D"/>
-                          </a:solidFill>
-                          <a:latin typeface="DejaVu Sans"/>
-                        </a:defRPr>
-                      </a:pPr>
-                      <a:r>
-                        <a:t>178.42%</a:t>
-                      </a:r>
-                    </a:p>
-                  </a:txBody>
-                  <a:tcPr marL="82296" marR="82296" marT="91440" marB="0" anchor="t">
-                    <a:lnL w="6350">
-                      <a:noFill/>
-                    </a:lnL>
-                    <a:lnR w="6350">
-                      <a:noFill/>
-                    </a:lnR>
-                    <a:lnT w="6350">
-                      <a:noFill/>
-                    </a:lnT>
-                    <a:lnB w="6350">
-                      <a:solidFill>
-                        <a:srgbClr val="D9DEE3"/>
-                      </a:solidFill>
-                    </a:lnB>
-                    <a:solidFill>
-                      <a:srgbClr val="FFFFFF"/>
-                    </a:solidFill>
-                  </a:tcPr>
-                </a:tc>
-                <a:tc>
-                  <a:txBody>
-                    <a:bodyPr wrap="none"/>
-                    <a:lstStyle/>
-                    <a:p>
-                      <a:pPr algn="r">
-                        <a:lnSpc>
-                          <a:spcPts val="1980"/>
-                        </a:lnSpc>
-                        <a:spcBef>
-                          <a:spcPts val="0"/>
-                        </a:spcBef>
-                        <a:spcAft>
-                          <a:spcPts val="0"/>
-                        </a:spcAft>
-                        <a:defRPr sz="1800" b="0">
-                          <a:solidFill>
-                            <a:srgbClr val="17212D"/>
-                          </a:solidFill>
-                          <a:latin typeface="DejaVu Sans"/>
-                        </a:defRPr>
-                      </a:pPr>
-                      <a:r>
-                        <a:t>5.56%</a:t>
-                      </a:r>
-                    </a:p>
-                  </a:txBody>
-                  <a:tcPr marL="82296" marR="82296" marT="91440" marB="0" anchor="t">
-                    <a:lnL w="6350">
-                      <a:noFill/>
-                    </a:lnL>
-                    <a:lnR w="6350">
-                      <a:noFill/>
-                    </a:lnR>
-                    <a:lnT w="6350">
-                      <a:noFill/>
-                    </a:lnT>
-                    <a:lnB w="6350">
-                      <a:solidFill>
-                        <a:srgbClr val="D9DEE3"/>
-                      </a:solidFill>
-                    </a:lnB>
-                    <a:solidFill>
-                      <a:srgbClr val="FFFFFF"/>
-                    </a:solidFill>
-                  </a:tcPr>
-                </a:tc>
-                <a:tc>
-                  <a:txBody>
-                    <a:bodyPr wrap="none"/>
-                    <a:lstStyle/>
-                    <a:p>
-                      <a:pPr algn="r">
-                        <a:lnSpc>
-                          <a:spcPts val="1980"/>
-                        </a:lnSpc>
-                        <a:spcBef>
-                          <a:spcPts val="0"/>
-                        </a:spcBef>
-                        <a:spcAft>
-                          <a:spcPts val="0"/>
-                        </a:spcAft>
-                        <a:defRPr sz="1800" b="0">
-                          <a:solidFill>
-                            <a:srgbClr val="17212D"/>
-                          </a:solidFill>
-                          <a:latin typeface="DejaVu Sans"/>
-                        </a:defRPr>
-                      </a:pPr>
-                      <a:r>
-                        <a:t>-2.40</a:t>
-                      </a:r>
-                    </a:p>
-                  </a:txBody>
-                  <a:tcPr marL="82296" marR="82296" marT="91440" marB="0" anchor="t">
-                    <a:lnL w="6350">
-                      <a:noFill/>
-                    </a:lnL>
-                    <a:lnR w="6350">
-                      <a:noFill/>
-                    </a:lnR>
-                    <a:lnT w="6350">
-                      <a:noFill/>
-                    </a:lnT>
-                    <a:lnB w="6350">
-                      <a:solidFill>
-                        <a:srgbClr val="D9DEE3"/>
-                      </a:solidFill>
-                    </a:lnB>
-                    <a:solidFill>
-                      <a:srgbClr val="FFFFFF"/>
-                    </a:solidFill>
-                  </a:tcPr>
-                </a:tc>
-              </a:tr>
-              <a:tr h="411480">
-                <a:tc>
-                  <a:txBody>
-                    <a:bodyPr wrap="none"/>
-                    <a:lstStyle/>
-                    <a:p>
-                      <a:pPr algn="l">
-                        <a:lnSpc>
-                          <a:spcPts val="1980"/>
-                        </a:lnSpc>
-                        <a:spcBef>
-                          <a:spcPts val="0"/>
-                        </a:spcBef>
-                        <a:spcAft>
-                          <a:spcPts val="0"/>
-                        </a:spcAft>
-                        <a:defRPr sz="1800" b="0">
-                          <a:solidFill>
-                            <a:srgbClr val="17212D"/>
-                          </a:solidFill>
-                          <a:latin typeface="DejaVu Sans"/>
-                        </a:defRPr>
-                      </a:pPr>
-                      <a:r>
-                        <a:t>Benchmark</a:t>
-                      </a:r>
-                    </a:p>
-                  </a:txBody>
-                  <a:tcPr marL="82296" marR="82296" marT="91440" marB="0" anchor="t">
-                    <a:lnL w="6350">
-                      <a:noFill/>
-                    </a:lnL>
-                    <a:lnR w="6350">
-                      <a:noFill/>
-                    </a:lnR>
-                    <a:lnT w="6350">
-                      <a:noFill/>
-                    </a:lnT>
-                    <a:lnB w="6350">
-                      <a:solidFill>
-                        <a:srgbClr val="D9DEE3"/>
-                      </a:solidFill>
-                    </a:lnB>
-                    <a:solidFill>
-                      <a:srgbClr val="FFFFFF"/>
-                    </a:solidFill>
-                  </a:tcPr>
-                </a:tc>
-                <a:tc>
-                  <a:txBody>
-                    <a:bodyPr wrap="none"/>
-                    <a:lstStyle/>
-                    <a:p>
-                      <a:pPr algn="r">
-                        <a:lnSpc>
-                          <a:spcPts val="1980"/>
-                        </a:lnSpc>
-                        <a:spcBef>
-                          <a:spcPts val="0"/>
-                        </a:spcBef>
-                        <a:spcAft>
-                          <a:spcPts val="0"/>
-                        </a:spcAft>
-                        <a:defRPr sz="1800" b="0">
-                          <a:solidFill>
-                            <a:srgbClr val="17212D"/>
-                          </a:solidFill>
-                          <a:latin typeface="DejaVu Sans"/>
-                        </a:defRPr>
-                      </a:pPr>
-                      <a:r>
-                        <a:t>76.60%</a:t>
-                      </a:r>
-                    </a:p>
-                  </a:txBody>
-                  <a:tcPr marL="82296" marR="82296" marT="91440" marB="0" anchor="t">
-                    <a:lnL w="6350">
-                      <a:noFill/>
-                    </a:lnL>
-                    <a:lnR w="6350">
-                      <a:noFill/>
-                    </a:lnR>
-                    <a:lnT w="6350">
-                      <a:noFill/>
-                    </a:lnT>
-                    <a:lnB w="6350">
-                      <a:solidFill>
-                        <a:srgbClr val="D9DEE3"/>
-                      </a:solidFill>
-                    </a:lnB>
-                    <a:solidFill>
-                      <a:srgbClr val="FFFFFF"/>
-                    </a:solidFill>
-                  </a:tcPr>
-                </a:tc>
-                <a:tc>
-                  <a:txBody>
-                    <a:bodyPr wrap="none"/>
-                    <a:lstStyle/>
-                    <a:p>
-                      <a:pPr algn="r">
-                        <a:lnSpc>
-                          <a:spcPts val="1980"/>
-                        </a:lnSpc>
-                        <a:spcBef>
-                          <a:spcPts val="0"/>
-                        </a:spcBef>
-                        <a:spcAft>
-                          <a:spcPts val="0"/>
-                        </a:spcAft>
-                        <a:defRPr sz="1800" b="0">
-                          <a:solidFill>
-                            <a:srgbClr val="17212D"/>
-                          </a:solidFill>
-                          <a:latin typeface="DejaVu Sans"/>
-                        </a:defRPr>
-                      </a:pPr>
-                      <a:r>
-                        <a:t>8.18%</a:t>
-                      </a:r>
-                    </a:p>
-                  </a:txBody>
-                  <a:tcPr marL="82296" marR="82296" marT="91440" marB="0" anchor="t">
-                    <a:lnL w="6350">
-                      <a:noFill/>
-                    </a:lnL>
-                    <a:lnR w="6350">
-                      <a:noFill/>
-                    </a:lnR>
-                    <a:lnT w="6350">
-                      <a:noFill/>
-                    </a:lnT>
-                    <a:lnB w="6350">
-                      <a:solidFill>
-                        <a:srgbClr val="D9DEE3"/>
-                      </a:solidFill>
-                    </a:lnB>
-                    <a:solidFill>
-                      <a:srgbClr val="FFFFFF"/>
-                    </a:solidFill>
-                  </a:tcPr>
-                </a:tc>
-                <a:tc>
-                  <a:txBody>
-                    <a:bodyPr wrap="none"/>
-                    <a:lstStyle/>
-                    <a:p>
-                      <a:pPr algn="r">
-                        <a:lnSpc>
-                          <a:spcPts val="1980"/>
-                        </a:lnSpc>
-                        <a:spcBef>
-                          <a:spcPts val="0"/>
-                        </a:spcBef>
-                        <a:spcAft>
-                          <a:spcPts val="0"/>
-                        </a:spcAft>
-                        <a:defRPr sz="1800" b="0">
-                          <a:solidFill>
-                            <a:srgbClr val="17212D"/>
-                          </a:solidFill>
-                          <a:latin typeface="DejaVu Sans"/>
-                        </a:defRPr>
-                      </a:pPr>
-                      <a:r>
-                        <a:t>+0.00</a:t>
                       </a:r>
                     </a:p>
                   </a:txBody>
@@ -10901,14 +9871,14 @@
       </p:graphicFrame>
       <p:sp>
         <p:nvSpPr>
-          <p:cNvPr id="11" name="TextBox 10"/>
+          <p:cNvPr id="5" name="TextBox 4"/>
           <p:cNvSpPr txBox="1"/>
           <p:nvPr/>
         </p:nvSpPr>
         <p:spPr>
           <a:xfrm>
-            <a:off x="896112" y="5989320"/>
-            <a:ext cx="10378440" cy="411480"/>
+            <a:off x="896112" y="4160520"/>
+            <a:ext cx="10378440" cy="457200"/>
           </a:xfrm>
           <a:prstGeom prst="rect">
             <a:avLst/>
@@ -10923,7 +9893,7 @@
           <a:p>
             <a:pPr algn="l">
               <a:lnSpc>
-                <a:spcPts val="2240"/>
+                <a:spcPts val="2128"/>
               </a:lnSpc>
               <a:spcBef>
                 <a:spcPts val="0"/>
@@ -10931,7 +9901,7 @@
               <a:spcAft>
                 <a:spcPts val="0"/>
               </a:spcAft>
-              <a:defRPr sz="2000" b="0">
+              <a:defRPr sz="1900" b="0">
                 <a:solidFill>
                   <a:srgbClr val="17212D"/>
                 </a:solidFill>
@@ -10939,14 +9909,149 @@
               </a:defRPr>
             </a:pPr>
             <a:r>
-              <a:t>Lasso improves development return; 2026 trails original Ridge.</a:t>
-            </a:r>
-          </a:p>
-        </p:txBody>
-      </p:sp>
-      <p:sp>
-        <p:nvSpPr>
-          <p:cNvPr id="12" name="TextBox 11"/>
+              <a:t>Ridge-exp: original expanding history · Lasso-3y: optimized three-year window</a:t>
+            </a:r>
+          </a:p>
+        </p:txBody>
+      </p:sp>
+      <p:sp>
+        <p:nvSpPr>
+          <p:cNvPr id="6" name="TextBox 5"/>
+          <p:cNvSpPr txBox="1"/>
+          <p:nvPr/>
+        </p:nvSpPr>
+        <p:spPr>
+          <a:xfrm>
+            <a:off x="896112" y="4818888"/>
+            <a:ext cx="10378440" cy="411480"/>
+          </a:xfrm>
+          <a:prstGeom prst="rect">
+            <a:avLst/>
+          </a:prstGeom>
+          <a:noFill/>
+        </p:spPr>
+        <p:txBody>
+          <a:bodyPr wrap="none" tIns="0" bIns="0" lIns="0" rIns="0" anchor="t">
+            <a:spAutoFit/>
+          </a:bodyPr>
+          <a:lstStyle/>
+          <a:p>
+            <a:pPr algn="l">
+              <a:lnSpc>
+                <a:spcPts val="2128"/>
+              </a:lnSpc>
+              <a:spcBef>
+                <a:spcPts val="0"/>
+              </a:spcBef>
+              <a:spcAft>
+                <a:spcPts val="0"/>
+              </a:spcAft>
+              <a:defRPr sz="1900" b="0">
+                <a:solidFill>
+                  <a:srgbClr val="17212D"/>
+                </a:solidFill>
+                <a:latin typeface="DejaVu Sans"/>
+              </a:defRPr>
+            </a:pPr>
+            <a:r>
+              <a:t>Full history includes 2018–2020 fitted replay; 2026 ends on 29 April.</a:t>
+            </a:r>
+          </a:p>
+        </p:txBody>
+      </p:sp>
+      <p:sp>
+        <p:nvSpPr>
+          <p:cNvPr id="7" name="TextBox 6"/>
+          <p:cNvSpPr txBox="1"/>
+          <p:nvPr/>
+        </p:nvSpPr>
+        <p:spPr>
+          <a:xfrm>
+            <a:off x="896112" y="5449824"/>
+            <a:ext cx="10378440" cy="411480"/>
+          </a:xfrm>
+          <a:prstGeom prst="rect">
+            <a:avLst/>
+          </a:prstGeom>
+          <a:noFill/>
+        </p:spPr>
+        <p:txBody>
+          <a:bodyPr wrap="none" tIns="0" bIns="0" lIns="0" rIns="0" anchor="t">
+            <a:spAutoFit/>
+          </a:bodyPr>
+          <a:lstStyle/>
+          <a:p>
+            <a:pPr algn="l">
+              <a:lnSpc>
+                <a:spcPts val="2016"/>
+              </a:lnSpc>
+              <a:spcBef>
+                <a:spcPts val="0"/>
+              </a:spcBef>
+              <a:spcAft>
+                <a:spcPts val="0"/>
+              </a:spcAft>
+              <a:defRPr sz="1800" b="0">
+                <a:solidFill>
+                  <a:srgbClr val="68737E"/>
+                </a:solidFill>
+                <a:latin typeface="DejaVu Sans"/>
+              </a:defRPr>
+            </a:pPr>
+            <a:r>
+              <a:t>Ridge-3y control is a separate development diagnostic, absent from the main curves.</a:t>
+            </a:r>
+          </a:p>
+        </p:txBody>
+      </p:sp>
+      <p:sp>
+        <p:nvSpPr>
+          <p:cNvPr id="8" name="TextBox 7"/>
+          <p:cNvSpPr txBox="1"/>
+          <p:nvPr/>
+        </p:nvSpPr>
+        <p:spPr>
+          <a:xfrm>
+            <a:off x="896112" y="6071616"/>
+            <a:ext cx="10378440" cy="365760"/>
+          </a:xfrm>
+          <a:prstGeom prst="rect">
+            <a:avLst/>
+          </a:prstGeom>
+          <a:noFill/>
+        </p:spPr>
+        <p:txBody>
+          <a:bodyPr wrap="none" tIns="0" bIns="0" lIns="0" rIns="0" anchor="t">
+            <a:spAutoFit/>
+          </a:bodyPr>
+          <a:lstStyle/>
+          <a:p>
+            <a:pPr algn="l">
+              <a:lnSpc>
+                <a:spcPts val="2240"/>
+              </a:lnSpc>
+              <a:spcBef>
+                <a:spcPts val="0"/>
+              </a:spcBef>
+              <a:spcAft>
+                <a:spcPts val="0"/>
+              </a:spcAft>
+              <a:defRPr sz="2000" b="1">
+                <a:solidFill>
+                  <a:srgbClr val="17212D"/>
+                </a:solidFill>
+                <a:latin typeface="DejaVu Sans"/>
+              </a:defRPr>
+            </a:pPr>
+            <a:r>
+              <a:t>Lasso-3y leads full/development; Ridge-exp leads 2026.</a:t>
+            </a:r>
+          </a:p>
+        </p:txBody>
+      </p:sp>
+      <p:sp>
+        <p:nvSpPr>
+          <p:cNvPr id="9" name="TextBox 8"/>
           <p:cNvSpPr txBox="1"/>
           <p:nvPr/>
         </p:nvSpPr>
@@ -11145,7 +10250,7 @@
               </a:defRPr>
             </a:pPr>
             <a:r>
-              <a:t>1 2021–2025: Ridge net 195.66%, pool 76.60%.</a:t>
+              <a:t>1 Full net: Lasso-3y 417.56%; Ridge-exp 395.35%.</a:t>
             </a:r>
           </a:p>
         </p:txBody>
@@ -11190,7 +10295,11 @@
               </a:defRPr>
             </a:pPr>
             <a:r>
-              <a:t>2 Lasso: 2021–2025 211.46%; 2026 3.35% net.</a:t>
+              <a:t>2 Development: Lasso-3y 211.46%, Ridge-exp 195.66%; 2026:</a:t>
+            </a:r>
+            <a:br/>
+            <a:r>
+              <a:t>3.35% vs 8.80%.</a:t>
             </a:r>
           </a:p>
         </p:txBody>
@@ -13945,7 +13054,7 @@
                         </a:defRPr>
                       </a:pPr>
                       <a:r>
-                        <a:t>Ridge</a:t>
+                        <a:t>Ridge-exp</a:t>
                       </a:r>
                     </a:p>
                   </a:txBody>
@@ -13992,7 +13101,7 @@
                         </a:defRPr>
                       </a:pPr>
                       <a:r>
-                        <a:t>alpha = 10,000</a:t>
+                        <a:t>Expanding history; alpha = 10,000</a:t>
                       </a:r>
                     </a:p>
                   </a:txBody>
@@ -14088,7 +13197,7 @@
                         </a:defRPr>
                       </a:pPr>
                       <a:r>
-                        <a:t>Lasso</a:t>
+                        <a:t>Lasso-3y</a:t>
                       </a:r>
                     </a:p>
                   </a:txBody>
@@ -14135,7 +13244,7 @@
                         </a:defRPr>
                       </a:pPr>
                       <a:r>
-                        <a:t>L1; 8 inputs; annual validation alpha</a:t>
+                        <a:t>8 inputs; 3-year history; validation alpha</a:t>
                       </a:r>
                     </a:p>
                   </a:txBody>
@@ -15351,7 +14460,7 @@
               </a:defRPr>
             </a:pPr>
             <a:r>
-              <a:t>All five methods and the equal-weight pool are shown over the full history.</a:t>
+              <a:t>Full gross: Lasso-3y 508.00%; Ridge-exp 480.94%.</a:t>
             </a:r>
           </a:p>
         </p:txBody>
@@ -15581,7 +14690,7 @@
               </a:defRPr>
             </a:pPr>
             <a:r>
-              <a:t>2021–2025: Ridge 195.66%; matched pool 76.60%.</a:t>
+              <a:t>Full net: Lasso-3y 417.56%; Ridge-exp 395.35%.</a:t>
             </a:r>
           </a:p>
         </p:txBody>

</xml_diff>